<commit_message>
docs: 优化 2026-08-05 日报 PPT 间距与换行
根据视觉 QA 调整卡片间距、正文宽度与页脚对比度，避免中文断词与拥挤布局。

Co-authored-by: 程序员鱼皮 <592789970@qq.com>
</commit_message>
<xml_diff>
--- a/docs/reports/project-status-2026-08-05.pptx
+++ b/docs/reports/project-status-2026-08-05.pptx
@@ -2248,7 +2248,7 @@
         <p:spPr>
           <a:xfrm>
             <a:off x="457200" y="1051560"/>
-            <a:ext cx="8229600" cy="1005840"/>
+            <a:ext cx="8229600" cy="1051560"/>
           </a:xfrm>
           <a:prstGeom prst="rect">
             <a:avLst/>
@@ -2275,7 +2275,7 @@
         </p:blipFill>
         <p:spPr>
           <a:xfrm>
-            <a:off x="685800" y="1280160"/>
+            <a:off x="685800" y="1234440"/>
             <a:ext cx="365760" cy="365760"/>
           </a:xfrm>
           <a:prstGeom prst="rect">
@@ -2291,8 +2291,8 @@
         </p:nvSpPr>
         <p:spPr>
           <a:xfrm>
-            <a:off x="1234440" y="1143000"/>
-            <a:ext cx="7132320" cy="365760"/>
+            <a:off x="1234440" y="1170432"/>
+            <a:ext cx="7223760" cy="320040"/>
           </a:xfrm>
           <a:prstGeom prst="rect">
             <a:avLst/>
@@ -2331,7 +2331,7 @@
         <p:spPr>
           <a:xfrm>
             <a:off x="1234440" y="1554480"/>
-            <a:ext cx="7132320" cy="365760"/>
+            <a:ext cx="7223760" cy="365760"/>
           </a:xfrm>
           <a:prstGeom prst="rect">
             <a:avLst/>
@@ -2355,7 +2355,7 @@
                 <a:ea typeface="Calibri" pitchFamily="34" charset="-122"/>
                 <a:cs typeface="Calibri" pitchFamily="34" charset="-120"/>
               </a:rPr>
-              <a:t>仓库未配置 Maven / Vue 的 GitHub Actions 门禁；最近 Actions 记录主要为 Copilot 仓库访问检查（均 success）。</a:t>
+              <a:t>未配置 Maven / Vue 的 GitHub Actions 门禁；近期记录主要为 Copilot 访问检查（均 success）。</a:t>
             </a:r>
             <a:endParaRPr lang="en-US" sz="1300" dirty="0"/>
           </a:p>
@@ -2369,8 +2369,8 @@
         </p:nvSpPr>
         <p:spPr>
           <a:xfrm>
-            <a:off x="457200" y="2286000"/>
-            <a:ext cx="2743200" cy="2103120"/>
+            <a:off x="457200" y="2331720"/>
+            <a:ext cx="2743200" cy="2057400"/>
           </a:xfrm>
           <a:prstGeom prst="rect">
             <a:avLst/>
@@ -2396,7 +2396,7 @@
         </p:nvSpPr>
         <p:spPr>
           <a:xfrm>
-            <a:off x="1463040" y="2468880"/>
+            <a:off x="1463040" y="2514600"/>
             <a:ext cx="640080" cy="640080"/>
           </a:xfrm>
           <a:prstGeom prst="ellipse">
@@ -2424,7 +2424,7 @@
         </p:blipFill>
         <p:spPr>
           <a:xfrm>
-            <a:off x="1600200" y="2606040"/>
+            <a:off x="1600200" y="2651760"/>
             <a:ext cx="365760" cy="365760"/>
           </a:xfrm>
           <a:prstGeom prst="rect">
@@ -2440,8 +2440,8 @@
         </p:nvSpPr>
         <p:spPr>
           <a:xfrm>
-            <a:off x="640080" y="3246120"/>
-            <a:ext cx="2377440" cy="320040"/>
+            <a:off x="594360" y="3291840"/>
+            <a:ext cx="2468880" cy="320040"/>
           </a:xfrm>
           <a:prstGeom prst="rect">
             <a:avLst/>
@@ -2479,8 +2479,8 @@
         </p:nvSpPr>
         <p:spPr>
           <a:xfrm>
-            <a:off x="640080" y="3611880"/>
-            <a:ext cx="2377440" cy="640080"/>
+            <a:off x="640080" y="3657600"/>
+            <a:ext cx="2377440" cy="548640"/>
           </a:xfrm>
           <a:prstGeom prst="rect">
             <a:avLst/>
@@ -2504,7 +2504,7 @@
                 <a:ea typeface="Calibri" pitchFamily="34" charset="-122"/>
                 <a:cs typeface="Calibri" pitchFamily="34" charset="-120"/>
               </a:rPr>
-              <a:t>14 个测试类：路由、门面、CodeParser、LangGraph 工作流与图片工具</a:t>
+              <a:t>14 个测试类覆盖路由、门面、解析与 LangGraph 工作流</a:t>
             </a:r>
             <a:endParaRPr lang="en-US" sz="1200" dirty="0"/>
           </a:p>
@@ -2518,8 +2518,8 @@
         </p:nvSpPr>
         <p:spPr>
           <a:xfrm>
-            <a:off x="3337560" y="2286000"/>
-            <a:ext cx="2743200" cy="2103120"/>
+            <a:off x="3383280" y="2331720"/>
+            <a:ext cx="2743200" cy="2057400"/>
           </a:xfrm>
           <a:prstGeom prst="rect">
             <a:avLst/>
@@ -2545,7 +2545,7 @@
         </p:nvSpPr>
         <p:spPr>
           <a:xfrm>
-            <a:off x="4343400" y="2468880"/>
+            <a:off x="4389120" y="2514600"/>
             <a:ext cx="640080" cy="640080"/>
           </a:xfrm>
           <a:prstGeom prst="ellipse">
@@ -2573,7 +2573,7 @@
         </p:blipFill>
         <p:spPr>
           <a:xfrm>
-            <a:off x="4480560" y="2606040"/>
+            <a:off x="4526280" y="2651760"/>
             <a:ext cx="365760" cy="365760"/>
           </a:xfrm>
           <a:prstGeom prst="rect">
@@ -2589,8 +2589,8 @@
         </p:nvSpPr>
         <p:spPr>
           <a:xfrm>
-            <a:off x="3520440" y="3246120"/>
-            <a:ext cx="2377440" cy="320040"/>
+            <a:off x="3520440" y="3291840"/>
+            <a:ext cx="2468880" cy="320040"/>
           </a:xfrm>
           <a:prstGeom prst="rect">
             <a:avLst/>
@@ -2628,8 +2628,8 @@
         </p:nvSpPr>
         <p:spPr>
           <a:xfrm>
-            <a:off x="3520440" y="3611880"/>
-            <a:ext cx="2377440" cy="640080"/>
+            <a:off x="3566160" y="3657600"/>
+            <a:ext cx="2377440" cy="548640"/>
           </a:xfrm>
           <a:prstGeom prst="rect">
             <a:avLst/>
@@ -2653,7 +2653,7 @@
                 <a:ea typeface="Calibri" pitchFamily="34" charset="-122"/>
                 <a:cs typeface="Calibri" pitchFamily="34" charset="-120"/>
               </a:rPr>
-              <a:t>含 type-check / lint / format；尚未在 CI 中自动执行</a:t>
+              <a:t>含 type-check / lint / format，尚未接入 CI</a:t>
             </a:r>
             <a:endParaRPr lang="en-US" sz="1200" dirty="0"/>
           </a:p>
@@ -2667,8 +2667,8 @@
         </p:nvSpPr>
         <p:spPr>
           <a:xfrm>
-            <a:off x="6217920" y="2286000"/>
-            <a:ext cx="2743200" cy="2103120"/>
+            <a:off x="6309360" y="2331720"/>
+            <a:ext cx="2743200" cy="2057400"/>
           </a:xfrm>
           <a:prstGeom prst="rect">
             <a:avLst/>
@@ -2694,7 +2694,7 @@
         </p:nvSpPr>
         <p:spPr>
           <a:xfrm>
-            <a:off x="7223760" y="2468880"/>
+            <a:off x="7315200" y="2514600"/>
             <a:ext cx="640080" cy="640080"/>
           </a:xfrm>
           <a:prstGeom prst="ellipse">
@@ -2722,7 +2722,7 @@
         </p:blipFill>
         <p:spPr>
           <a:xfrm>
-            <a:off x="7360920" y="2606040"/>
+            <a:off x="7452360" y="2651760"/>
             <a:ext cx="365760" cy="365760"/>
           </a:xfrm>
           <a:prstGeom prst="rect">
@@ -2738,8 +2738,8 @@
         </p:nvSpPr>
         <p:spPr>
           <a:xfrm>
-            <a:off x="6400800" y="3246120"/>
-            <a:ext cx="2377440" cy="320040"/>
+            <a:off x="6446520" y="3291840"/>
+            <a:ext cx="2468880" cy="320040"/>
           </a:xfrm>
           <a:prstGeom prst="rect">
             <a:avLst/>
@@ -2777,8 +2777,8 @@
         </p:nvSpPr>
         <p:spPr>
           <a:xfrm>
-            <a:off x="6400800" y="3611880"/>
-            <a:ext cx="2377440" cy="640080"/>
+            <a:off x="6492240" y="3657600"/>
+            <a:ext cx="2377440" cy="548640"/>
           </a:xfrm>
           <a:prstGeom prst="rect">
             <a:avLst/>
@@ -2802,7 +2802,7 @@
                 <a:ea typeface="Calibri" pitchFamily="34" charset="-122"/>
                 <a:cs typeface="Calibri" pitchFamily="34" charset="-120"/>
               </a:rPr>
-              <a:t>prometheus.yml 与 Grafana AI 面板配置文件已就绪</a:t>
+              <a:t>prometheus.yml 与 Grafana AI 面板已就绪</a:t>
             </a:r>
             <a:endParaRPr lang="en-US" sz="1200" dirty="0"/>
           </a:p>
@@ -2816,7 +2816,7 @@
         </p:nvSpPr>
         <p:spPr>
           <a:xfrm>
-            <a:off x="457200" y="4800600"/>
+            <a:off x="457200" y="4828032"/>
             <a:ext cx="8229600" cy="228600"/>
           </a:xfrm>
           <a:prstGeom prst="rect">
@@ -2833,9 +2833,9 @@
               <a:buNone/>
             </a:pPr>
             <a:r>
-              <a:rPr lang="en-US" sz="1000" dirty="0">
-                <a:solidFill>
-                  <a:srgbClr val="64748B"/>
+              <a:rPr lang="en-US" sz="1100" dirty="0">
+                <a:solidFill>
+                  <a:srgbClr val="475569"/>
                 </a:solidFill>
                 <a:latin typeface="Calibri" pitchFamily="34" charset="0"/>
                 <a:ea typeface="Calibri" pitchFamily="34" charset="-122"/>
@@ -2843,7 +2843,7 @@
               </a:rPr>
               <a:t>yu-ai-code-mother  ·  每日项目状态  ·  2026-08-05</a:t>
             </a:r>
-            <a:endParaRPr lang="en-US" sz="1000" dirty="0"/>
+            <a:endParaRPr lang="en-US" sz="1100" dirty="0"/>
           </a:p>
         </p:txBody>
       </p:sp>
@@ -2985,14 +2985,14 @@
         </p:nvSpPr>
         <p:spPr>
           <a:xfrm>
-            <a:off x="548640" y="1600200"/>
-            <a:ext cx="411480" cy="411480"/>
+            <a:off x="548640" y="1554480"/>
+            <a:ext cx="438912" cy="438912"/>
           </a:xfrm>
           <a:prstGeom prst="ellipse">
             <a:avLst/>
           </a:prstGeom>
           <a:solidFill>
-            <a:srgbClr val="028090"/>
+            <a:srgbClr val="02C39A"/>
           </a:solidFill>
           <a:ln/>
         </p:spPr>
@@ -3005,8 +3005,8 @@
         </p:nvSpPr>
         <p:spPr>
           <a:xfrm>
-            <a:off x="548640" y="1600200"/>
-            <a:ext cx="411480" cy="411480"/>
+            <a:off x="548640" y="1554480"/>
+            <a:ext cx="438912" cy="438912"/>
           </a:xfrm>
           <a:prstGeom prst="rect">
             <a:avLst/>
@@ -3024,7 +3024,7 @@
             <a:r>
               <a:rPr lang="en-US" sz="1400" b="1" dirty="0">
                 <a:solidFill>
-                  <a:srgbClr val="FFFFFF"/>
+                  <a:srgbClr val="063540"/>
                 </a:solidFill>
                 <a:latin typeface="Calibri" pitchFamily="34" charset="0"/>
                 <a:ea typeface="Calibri" pitchFamily="34" charset="-122"/>
@@ -3044,7 +3044,7 @@
         </p:nvSpPr>
         <p:spPr>
           <a:xfrm>
-            <a:off x="1188720" y="1554480"/>
+            <a:off x="1188720" y="1508760"/>
             <a:ext cx="7315200" cy="502920"/>
           </a:xfrm>
           <a:prstGeom prst="rect">
@@ -3083,14 +3083,14 @@
         </p:nvSpPr>
         <p:spPr>
           <a:xfrm>
-            <a:off x="548640" y="2286000"/>
-            <a:ext cx="411480" cy="411480"/>
+            <a:off x="548640" y="2267712"/>
+            <a:ext cx="438912" cy="438912"/>
           </a:xfrm>
           <a:prstGeom prst="ellipse">
             <a:avLst/>
           </a:prstGeom>
           <a:solidFill>
-            <a:srgbClr val="028090"/>
+            <a:srgbClr val="02C39A"/>
           </a:solidFill>
           <a:ln/>
         </p:spPr>
@@ -3103,8 +3103,8 @@
         </p:nvSpPr>
         <p:spPr>
           <a:xfrm>
-            <a:off x="548640" y="2286000"/>
-            <a:ext cx="411480" cy="411480"/>
+            <a:off x="548640" y="2267712"/>
+            <a:ext cx="438912" cy="438912"/>
           </a:xfrm>
           <a:prstGeom prst="rect">
             <a:avLst/>
@@ -3122,7 +3122,7 @@
             <a:r>
               <a:rPr lang="en-US" sz="1400" b="1" dirty="0">
                 <a:solidFill>
-                  <a:srgbClr val="FFFFFF"/>
+                  <a:srgbClr val="063540"/>
                 </a:solidFill>
                 <a:latin typeface="Calibri" pitchFamily="34" charset="0"/>
                 <a:ea typeface="Calibri" pitchFamily="34" charset="-122"/>
@@ -3142,7 +3142,7 @@
         </p:nvSpPr>
         <p:spPr>
           <a:xfrm>
-            <a:off x="1188720" y="2240280"/>
+            <a:off x="1188720" y="2221992"/>
             <a:ext cx="7315200" cy="502920"/>
           </a:xfrm>
           <a:prstGeom prst="rect">
@@ -3181,14 +3181,14 @@
         </p:nvSpPr>
         <p:spPr>
           <a:xfrm>
-            <a:off x="548640" y="2971800"/>
-            <a:ext cx="411480" cy="411480"/>
+            <a:off x="548640" y="2980944"/>
+            <a:ext cx="438912" cy="438912"/>
           </a:xfrm>
           <a:prstGeom prst="ellipse">
             <a:avLst/>
           </a:prstGeom>
           <a:solidFill>
-            <a:srgbClr val="028090"/>
+            <a:srgbClr val="02C39A"/>
           </a:solidFill>
           <a:ln/>
         </p:spPr>
@@ -3201,8 +3201,8 @@
         </p:nvSpPr>
         <p:spPr>
           <a:xfrm>
-            <a:off x="548640" y="2971800"/>
-            <a:ext cx="411480" cy="411480"/>
+            <a:off x="548640" y="2980944"/>
+            <a:ext cx="438912" cy="438912"/>
           </a:xfrm>
           <a:prstGeom prst="rect">
             <a:avLst/>
@@ -3220,7 +3220,7 @@
             <a:r>
               <a:rPr lang="en-US" sz="1400" b="1" dirty="0">
                 <a:solidFill>
-                  <a:srgbClr val="FFFFFF"/>
+                  <a:srgbClr val="063540"/>
                 </a:solidFill>
                 <a:latin typeface="Calibri" pitchFamily="34" charset="0"/>
                 <a:ea typeface="Calibri" pitchFamily="34" charset="-122"/>
@@ -3240,7 +3240,7 @@
         </p:nvSpPr>
         <p:spPr>
           <a:xfrm>
-            <a:off x="1188720" y="2926080"/>
+            <a:off x="1188720" y="2935224"/>
             <a:ext cx="7315200" cy="502920"/>
           </a:xfrm>
           <a:prstGeom prst="rect">
@@ -3279,14 +3279,14 @@
         </p:nvSpPr>
         <p:spPr>
           <a:xfrm>
-            <a:off x="548640" y="3657600"/>
-            <a:ext cx="411480" cy="411480"/>
+            <a:off x="548640" y="3694176"/>
+            <a:ext cx="438912" cy="438912"/>
           </a:xfrm>
           <a:prstGeom prst="ellipse">
             <a:avLst/>
           </a:prstGeom>
           <a:solidFill>
-            <a:srgbClr val="028090"/>
+            <a:srgbClr val="02C39A"/>
           </a:solidFill>
           <a:ln/>
         </p:spPr>
@@ -3299,8 +3299,8 @@
         </p:nvSpPr>
         <p:spPr>
           <a:xfrm>
-            <a:off x="548640" y="3657600"/>
-            <a:ext cx="411480" cy="411480"/>
+            <a:off x="548640" y="3694176"/>
+            <a:ext cx="438912" cy="438912"/>
           </a:xfrm>
           <a:prstGeom prst="rect">
             <a:avLst/>
@@ -3318,7 +3318,7 @@
             <a:r>
               <a:rPr lang="en-US" sz="1400" b="1" dirty="0">
                 <a:solidFill>
-                  <a:srgbClr val="FFFFFF"/>
+                  <a:srgbClr val="063540"/>
                 </a:solidFill>
                 <a:latin typeface="Calibri" pitchFamily="34" charset="0"/>
                 <a:ea typeface="Calibri" pitchFamily="34" charset="-122"/>
@@ -3338,7 +3338,7 @@
         </p:nvSpPr>
         <p:spPr>
           <a:xfrm>
-            <a:off x="1188720" y="3611880"/>
+            <a:off x="1188720" y="3648456"/>
             <a:ext cx="7315200" cy="502920"/>
           </a:xfrm>
           <a:prstGeom prst="rect">
@@ -3377,7 +3377,7 @@
         </p:nvSpPr>
         <p:spPr>
           <a:xfrm>
-            <a:off x="457200" y="4800600"/>
+            <a:off x="457200" y="4828032"/>
             <a:ext cx="8229600" cy="228600"/>
           </a:xfrm>
           <a:prstGeom prst="rect">
@@ -3394,9 +3394,9 @@
               <a:buNone/>
             </a:pPr>
             <a:r>
-              <a:rPr lang="en-US" sz="1000" dirty="0">
-                <a:solidFill>
-                  <a:srgbClr val="8FBDB8"/>
+              <a:rPr lang="en-US" sz="1100" dirty="0">
+                <a:solidFill>
+                  <a:srgbClr val="A8D4CE"/>
                 </a:solidFill>
                 <a:latin typeface="Calibri" pitchFamily="34" charset="0"/>
                 <a:ea typeface="Calibri" pitchFamily="34" charset="-122"/>
@@ -3404,7 +3404,7 @@
               </a:rPr>
               <a:t>yu-ai-code-mother  ·  每日项目状态  ·  2026-08-05</a:t>
             </a:r>
-            <a:endParaRPr lang="en-US" sz="1000" dirty="0"/>
+            <a:endParaRPr lang="en-US" sz="1100" dirty="0"/>
           </a:p>
         </p:txBody>
       </p:sp>
@@ -3716,7 +3716,7 @@
         <p:spPr>
           <a:xfrm>
             <a:off x="1645920" y="2331720"/>
-            <a:ext cx="3657600" cy="320040"/>
+            <a:ext cx="3703320" cy="320040"/>
           </a:xfrm>
           <a:prstGeom prst="rect">
             <a:avLst/>
@@ -3740,7 +3740,7 @@
                 <a:ea typeface="Calibri" pitchFamily="34" charset="-122"/>
                 <a:cs typeface="Calibri" pitchFamily="34" charset="-120"/>
               </a:rPr>
-              <a:t>Spring Boot 3.5 / Java 21 / LangChain4j / LangGraph4j</a:t>
+              <a:t>Spring Boot 3.5 · Java 21 · LangChain4j</a:t>
             </a:r>
             <a:endParaRPr lang="en-US" sz="1300" dirty="0"/>
           </a:p>
@@ -3794,7 +3794,7 @@
         <p:spPr>
           <a:xfrm>
             <a:off x="1645920" y="2788920"/>
-            <a:ext cx="3657600" cy="320040"/>
+            <a:ext cx="3703320" cy="320040"/>
           </a:xfrm>
           <a:prstGeom prst="rect">
             <a:avLst/>
@@ -3818,7 +3818,7 @@
                 <a:ea typeface="Calibri" pitchFamily="34" charset="-122"/>
                 <a:cs typeface="Calibri" pitchFamily="34" charset="-120"/>
               </a:rPr>
-              <a:t>Vue 3 + Vite + Ant Design Vue + Pinia</a:t>
+              <a:t>Vue 3 · Vite · Ant Design Vue · Pinia</a:t>
             </a:r>
             <a:endParaRPr lang="en-US" sz="1300" dirty="0"/>
           </a:p>
@@ -3872,7 +3872,7 @@
         <p:spPr>
           <a:xfrm>
             <a:off x="1645920" y="3246120"/>
-            <a:ext cx="3657600" cy="320040"/>
+            <a:ext cx="3703320" cy="320040"/>
           </a:xfrm>
           <a:prstGeom prst="rect">
             <a:avLst/>
@@ -3950,7 +3950,7 @@
         <p:spPr>
           <a:xfrm>
             <a:off x="1645920" y="3703320"/>
-            <a:ext cx="3657600" cy="320040"/>
+            <a:ext cx="3703320" cy="320040"/>
           </a:xfrm>
           <a:prstGeom prst="rect">
             <a:avLst/>
@@ -3988,8 +3988,8 @@
         </p:nvSpPr>
         <p:spPr>
           <a:xfrm>
-            <a:off x="5852160" y="1005840"/>
-            <a:ext cx="2834640" cy="777240"/>
+            <a:off x="5806440" y="1005840"/>
+            <a:ext cx="2880360" cy="749808"/>
           </a:xfrm>
           <a:prstGeom prst="rect">
             <a:avLst/>
@@ -4015,8 +4015,8 @@
         </p:nvSpPr>
         <p:spPr>
           <a:xfrm>
-            <a:off x="5852160" y="1005840"/>
-            <a:ext cx="91440" cy="777240"/>
+            <a:off x="5806440" y="1005840"/>
+            <a:ext cx="91440" cy="749808"/>
           </a:xfrm>
           <a:prstGeom prst="rect">
             <a:avLst/>
@@ -4035,24 +4035,24 @@
         </p:nvSpPr>
         <p:spPr>
           <a:xfrm>
-            <a:off x="6126480" y="1078992"/>
-            <a:ext cx="1097280" cy="640080"/>
-          </a:xfrm>
-          <a:prstGeom prst="rect">
-            <a:avLst/>
-          </a:prstGeom>
-          <a:noFill/>
-          <a:ln/>
-        </p:spPr>
-        <p:txBody>
-          <a:bodyPr wrap="square" lIns="0" tIns="0" rIns="0" bIns="0" rtlCol="0" anchor="ctr"/>
-          <a:lstStyle/>
-          <a:p>
-            <a:pPr indent="0" marL="0">
-              <a:buNone/>
-            </a:pPr>
-            <a:r>
-              <a:rPr lang="en-US" sz="3200" b="1" dirty="0">
+            <a:off x="6080760" y="1078992"/>
+            <a:ext cx="1005840" cy="603504"/>
+          </a:xfrm>
+          <a:prstGeom prst="rect">
+            <a:avLst/>
+          </a:prstGeom>
+          <a:noFill/>
+          <a:ln/>
+        </p:spPr>
+        <p:txBody>
+          <a:bodyPr wrap="square" lIns="0" tIns="0" rIns="0" bIns="0" rtlCol="0" anchor="ctr"/>
+          <a:lstStyle/>
+          <a:p>
+            <a:pPr indent="0" marL="0">
+              <a:buNone/>
+            </a:pPr>
+            <a:r>
+              <a:rPr lang="en-US" sz="3000" b="1" dirty="0">
                 <a:solidFill>
                   <a:srgbClr val="028090"/>
                 </a:solidFill>
@@ -4062,7 +4062,7 @@
               </a:rPr>
               <a:t>4</a:t>
             </a:r>
-            <a:endParaRPr lang="en-US" sz="3200" dirty="0"/>
+            <a:endParaRPr lang="en-US" sz="3000" dirty="0"/>
           </a:p>
         </p:txBody>
       </p:sp>
@@ -4074,8 +4074,8 @@
         </p:nvSpPr>
         <p:spPr>
           <a:xfrm>
-            <a:off x="7223760" y="1188720"/>
-            <a:ext cx="1280160" cy="411480"/>
+            <a:off x="7132320" y="1170432"/>
+            <a:ext cx="1371600" cy="411480"/>
           </a:xfrm>
           <a:prstGeom prst="rect">
             <a:avLst/>
@@ -4113,8 +4113,8 @@
         </p:nvSpPr>
         <p:spPr>
           <a:xfrm>
-            <a:off x="5852160" y="1874520"/>
-            <a:ext cx="2834640" cy="777240"/>
+            <a:off x="5806440" y="1874520"/>
+            <a:ext cx="2880360" cy="749808"/>
           </a:xfrm>
           <a:prstGeom prst="rect">
             <a:avLst/>
@@ -4140,8 +4140,8 @@
         </p:nvSpPr>
         <p:spPr>
           <a:xfrm>
-            <a:off x="5852160" y="1874520"/>
-            <a:ext cx="91440" cy="777240"/>
+            <a:off x="5806440" y="1874520"/>
+            <a:ext cx="91440" cy="749808"/>
           </a:xfrm>
           <a:prstGeom prst="rect">
             <a:avLst/>
@@ -4160,24 +4160,24 @@
         </p:nvSpPr>
         <p:spPr>
           <a:xfrm>
-            <a:off x="6126480" y="1947672"/>
-            <a:ext cx="1097280" cy="640080"/>
-          </a:xfrm>
-          <a:prstGeom prst="rect">
-            <a:avLst/>
-          </a:prstGeom>
-          <a:noFill/>
-          <a:ln/>
-        </p:spPr>
-        <p:txBody>
-          <a:bodyPr wrap="square" lIns="0" tIns="0" rIns="0" bIns="0" rtlCol="0" anchor="ctr"/>
-          <a:lstStyle/>
-          <a:p>
-            <a:pPr indent="0" marL="0">
-              <a:buNone/>
-            </a:pPr>
-            <a:r>
-              <a:rPr lang="en-US" sz="3200" b="1" dirty="0">
+            <a:off x="6080760" y="1947672"/>
+            <a:ext cx="1005840" cy="603504"/>
+          </a:xfrm>
+          <a:prstGeom prst="rect">
+            <a:avLst/>
+          </a:prstGeom>
+          <a:noFill/>
+          <a:ln/>
+        </p:spPr>
+        <p:txBody>
+          <a:bodyPr wrap="square" lIns="0" tIns="0" rIns="0" bIns="0" rtlCol="0" anchor="ctr"/>
+          <a:lstStyle/>
+          <a:p>
+            <a:pPr indent="0" marL="0">
+              <a:buNone/>
+            </a:pPr>
+            <a:r>
+              <a:rPr lang="en-US" sz="3000" b="1" dirty="0">
                 <a:solidFill>
                   <a:srgbClr val="00A896"/>
                 </a:solidFill>
@@ -4187,7 +4187,7 @@
               </a:rPr>
               <a:t>7</a:t>
             </a:r>
-            <a:endParaRPr lang="en-US" sz="3200" dirty="0"/>
+            <a:endParaRPr lang="en-US" sz="3000" dirty="0"/>
           </a:p>
         </p:txBody>
       </p:sp>
@@ -4199,8 +4199,8 @@
         </p:nvSpPr>
         <p:spPr>
           <a:xfrm>
-            <a:off x="7223760" y="2057400"/>
-            <a:ext cx="1280160" cy="411480"/>
+            <a:off x="7132320" y="2039112"/>
+            <a:ext cx="1371600" cy="411480"/>
           </a:xfrm>
           <a:prstGeom prst="rect">
             <a:avLst/>
@@ -4238,8 +4238,8 @@
         </p:nvSpPr>
         <p:spPr>
           <a:xfrm>
-            <a:off x="5852160" y="2743200"/>
-            <a:ext cx="2834640" cy="777240"/>
+            <a:off x="5806440" y="2743200"/>
+            <a:ext cx="2880360" cy="749808"/>
           </a:xfrm>
           <a:prstGeom prst="rect">
             <a:avLst/>
@@ -4265,14 +4265,14 @@
         </p:nvSpPr>
         <p:spPr>
           <a:xfrm>
-            <a:off x="5852160" y="2743200"/>
-            <a:ext cx="91440" cy="777240"/>
-          </a:xfrm>
-          <a:prstGeom prst="rect">
-            <a:avLst/>
-          </a:prstGeom>
-          <a:solidFill>
-            <a:srgbClr val="02C39A"/>
+            <a:off x="5806440" y="2743200"/>
+            <a:ext cx="91440" cy="749808"/>
+          </a:xfrm>
+          <a:prstGeom prst="rect">
+            <a:avLst/>
+          </a:prstGeom>
+          <a:solidFill>
+            <a:srgbClr val="028090"/>
           </a:solidFill>
           <a:ln/>
         </p:spPr>
@@ -4285,26 +4285,26 @@
         </p:nvSpPr>
         <p:spPr>
           <a:xfrm>
-            <a:off x="6126480" y="2816352"/>
-            <a:ext cx="1097280" cy="640080"/>
-          </a:xfrm>
-          <a:prstGeom prst="rect">
-            <a:avLst/>
-          </a:prstGeom>
-          <a:noFill/>
-          <a:ln/>
-        </p:spPr>
-        <p:txBody>
-          <a:bodyPr wrap="square" lIns="0" tIns="0" rIns="0" bIns="0" rtlCol="0" anchor="ctr"/>
-          <a:lstStyle/>
-          <a:p>
-            <a:pPr indent="0" marL="0">
-              <a:buNone/>
-            </a:pPr>
-            <a:r>
-              <a:rPr lang="en-US" sz="3200" b="1" dirty="0">
-                <a:solidFill>
-                  <a:srgbClr val="02C39A"/>
+            <a:off x="6080760" y="2816352"/>
+            <a:ext cx="1005840" cy="603504"/>
+          </a:xfrm>
+          <a:prstGeom prst="rect">
+            <a:avLst/>
+          </a:prstGeom>
+          <a:noFill/>
+          <a:ln/>
+        </p:spPr>
+        <p:txBody>
+          <a:bodyPr wrap="square" lIns="0" tIns="0" rIns="0" bIns="0" rtlCol="0" anchor="ctr"/>
+          <a:lstStyle/>
+          <a:p>
+            <a:pPr indent="0" marL="0">
+              <a:buNone/>
+            </a:pPr>
+            <a:r>
+              <a:rPr lang="en-US" sz="3000" b="1" dirty="0">
+                <a:solidFill>
+                  <a:srgbClr val="028090"/>
                 </a:solidFill>
                 <a:latin typeface="Georgia" pitchFamily="34" charset="0"/>
                 <a:ea typeface="Georgia" pitchFamily="34" charset="-122"/>
@@ -4312,7 +4312,7 @@
               </a:rPr>
               <a:t>14</a:t>
             </a:r>
-            <a:endParaRPr lang="en-US" sz="3200" dirty="0"/>
+            <a:endParaRPr lang="en-US" sz="3000" dirty="0"/>
           </a:p>
         </p:txBody>
       </p:sp>
@@ -4324,8 +4324,8 @@
         </p:nvSpPr>
         <p:spPr>
           <a:xfrm>
-            <a:off x="7223760" y="2926080"/>
-            <a:ext cx="1280160" cy="411480"/>
+            <a:off x="7132320" y="2907792"/>
+            <a:ext cx="1371600" cy="411480"/>
           </a:xfrm>
           <a:prstGeom prst="rect">
             <a:avLst/>
@@ -4363,8 +4363,8 @@
         </p:nvSpPr>
         <p:spPr>
           <a:xfrm>
-            <a:off x="5852160" y="3611880"/>
-            <a:ext cx="2834640" cy="777240"/>
+            <a:off x="5806440" y="3611880"/>
+            <a:ext cx="2880360" cy="749808"/>
           </a:xfrm>
           <a:prstGeom prst="rect">
             <a:avLst/>
@@ -4390,14 +4390,14 @@
         </p:nvSpPr>
         <p:spPr>
           <a:xfrm>
-            <a:off x="5852160" y="3611880"/>
-            <a:ext cx="91440" cy="777240"/>
-          </a:xfrm>
-          <a:prstGeom prst="rect">
-            <a:avLst/>
-          </a:prstGeom>
-          <a:solidFill>
-            <a:srgbClr val="0A3D4A"/>
+            <a:off x="5806440" y="3611880"/>
+            <a:ext cx="91440" cy="749808"/>
+          </a:xfrm>
+          <a:prstGeom prst="rect">
+            <a:avLst/>
+          </a:prstGeom>
+          <a:solidFill>
+            <a:srgbClr val="00A896"/>
           </a:solidFill>
           <a:ln/>
         </p:spPr>
@@ -4410,26 +4410,26 @@
         </p:nvSpPr>
         <p:spPr>
           <a:xfrm>
-            <a:off x="6126480" y="3685032"/>
-            <a:ext cx="1097280" cy="640080"/>
-          </a:xfrm>
-          <a:prstGeom prst="rect">
-            <a:avLst/>
-          </a:prstGeom>
-          <a:noFill/>
-          <a:ln/>
-        </p:spPr>
-        <p:txBody>
-          <a:bodyPr wrap="square" lIns="0" tIns="0" rIns="0" bIns="0" rtlCol="0" anchor="ctr"/>
-          <a:lstStyle/>
-          <a:p>
-            <a:pPr indent="0" marL="0">
-              <a:buNone/>
-            </a:pPr>
-            <a:r>
-              <a:rPr lang="en-US" sz="3200" b="1" dirty="0">
-                <a:solidFill>
-                  <a:srgbClr val="0A3D4A"/>
+            <a:off x="6080760" y="3685032"/>
+            <a:ext cx="1005840" cy="603504"/>
+          </a:xfrm>
+          <a:prstGeom prst="rect">
+            <a:avLst/>
+          </a:prstGeom>
+          <a:noFill/>
+          <a:ln/>
+        </p:spPr>
+        <p:txBody>
+          <a:bodyPr wrap="square" lIns="0" tIns="0" rIns="0" bIns="0" rtlCol="0" anchor="ctr"/>
+          <a:lstStyle/>
+          <a:p>
+            <a:pPr indent="0" marL="0">
+              <a:buNone/>
+            </a:pPr>
+            <a:r>
+              <a:rPr lang="en-US" sz="3000" b="1" dirty="0">
+                <a:solidFill>
+                  <a:srgbClr val="00A896"/>
                 </a:solidFill>
                 <a:latin typeface="Georgia" pitchFamily="34" charset="0"/>
                 <a:ea typeface="Georgia" pitchFamily="34" charset="-122"/>
@@ -4437,7 +4437,7 @@
               </a:rPr>
               <a:t>6</a:t>
             </a:r>
-            <a:endParaRPr lang="en-US" sz="3200" dirty="0"/>
+            <a:endParaRPr lang="en-US" sz="3000" dirty="0"/>
           </a:p>
         </p:txBody>
       </p:sp>
@@ -4449,8 +4449,8 @@
         </p:nvSpPr>
         <p:spPr>
           <a:xfrm>
-            <a:off x="7223760" y="3794760"/>
-            <a:ext cx="1280160" cy="411480"/>
+            <a:off x="7132320" y="3776472"/>
+            <a:ext cx="1371600" cy="411480"/>
           </a:xfrm>
           <a:prstGeom prst="rect">
             <a:avLst/>
@@ -4488,7 +4488,7 @@
         </p:nvSpPr>
         <p:spPr>
           <a:xfrm>
-            <a:off x="457200" y="4800600"/>
+            <a:off x="457200" y="4828032"/>
             <a:ext cx="8229600" cy="228600"/>
           </a:xfrm>
           <a:prstGeom prst="rect">
@@ -4505,9 +4505,9 @@
               <a:buNone/>
             </a:pPr>
             <a:r>
-              <a:rPr lang="en-US" sz="1000" dirty="0">
-                <a:solidFill>
-                  <a:srgbClr val="64748B"/>
+              <a:rPr lang="en-US" sz="1100" dirty="0">
+                <a:solidFill>
+                  <a:srgbClr val="475569"/>
                 </a:solidFill>
                 <a:latin typeface="Calibri" pitchFamily="34" charset="0"/>
                 <a:ea typeface="Calibri" pitchFamily="34" charset="-122"/>
@@ -4515,7 +4515,7 @@
               </a:rPr>
               <a:t>yu-ai-code-mother  ·  每日项目状态  ·  2026-08-05</a:t>
             </a:r>
-            <a:endParaRPr lang="en-US" sz="1000" dirty="0"/>
+            <a:endParaRPr lang="en-US" sz="1100" dirty="0"/>
           </a:p>
         </p:txBody>
       </p:sp>
@@ -4619,7 +4619,7 @@
         <p:spPr>
           <a:xfrm>
             <a:off x="457200" y="1051560"/>
-            <a:ext cx="4023360" cy="1508760"/>
+            <a:ext cx="4069080" cy="1554480"/>
           </a:xfrm>
           <a:prstGeom prst="rect">
             <a:avLst/>
@@ -4645,8 +4645,8 @@
         </p:nvSpPr>
         <p:spPr>
           <a:xfrm>
-            <a:off x="685800" y="1463040"/>
-            <a:ext cx="640080" cy="640080"/>
+            <a:off x="685800" y="1508760"/>
+            <a:ext cx="594360" cy="594360"/>
           </a:xfrm>
           <a:prstGeom prst="ellipse">
             <a:avLst/>
@@ -4673,7 +4673,7 @@
         </p:blipFill>
         <p:spPr>
           <a:xfrm>
-            <a:off x="822960" y="1600200"/>
+            <a:off x="804672" y="1627632"/>
             <a:ext cx="365760" cy="365760"/>
           </a:xfrm>
           <a:prstGeom prst="rect">
@@ -4689,8 +4689,8 @@
         </p:nvSpPr>
         <p:spPr>
           <a:xfrm>
-            <a:off x="1508760" y="1325880"/>
-            <a:ext cx="2743200" cy="365760"/>
+            <a:off x="1463040" y="1371600"/>
+            <a:ext cx="2834640" cy="365760"/>
           </a:xfrm>
           <a:prstGeom prst="rect">
             <a:avLst/>
@@ -4728,8 +4728,8 @@
         </p:nvSpPr>
         <p:spPr>
           <a:xfrm>
-            <a:off x="1508760" y="1783080"/>
-            <a:ext cx="2743200" cy="594360"/>
+            <a:off x="1463040" y="1828800"/>
+            <a:ext cx="2834640" cy="548640"/>
           </a:xfrm>
           <a:prstGeom prst="rect">
             <a:avLst/>
@@ -4753,7 +4753,7 @@
                 <a:ea typeface="Calibri" pitchFamily="34" charset="-122"/>
                 <a:cs typeface="Calibri" pitchFamily="34" charset="-120"/>
               </a:rPr>
-              <a:t>需求描述 → 策略路由 → 工具调用写文件，SSE 流式展示执行过程</a:t>
+              <a:t>需求描述 → 策略路由 → 工具写文件，SSE 流式展示过程</a:t>
             </a:r>
             <a:endParaRPr lang="en-US" sz="1300" dirty="0"/>
           </a:p>
@@ -4767,8 +4767,8 @@
         </p:nvSpPr>
         <p:spPr>
           <a:xfrm>
-            <a:off x="4754880" y="1051560"/>
-            <a:ext cx="4023360" cy="1508760"/>
+            <a:off x="4800600" y="1051560"/>
+            <a:ext cx="4069080" cy="1554480"/>
           </a:xfrm>
           <a:prstGeom prst="rect">
             <a:avLst/>
@@ -4794,8 +4794,8 @@
         </p:nvSpPr>
         <p:spPr>
           <a:xfrm>
-            <a:off x="4983480" y="1463040"/>
-            <a:ext cx="640080" cy="640080"/>
+            <a:off x="5029200" y="1508760"/>
+            <a:ext cx="594360" cy="594360"/>
           </a:xfrm>
           <a:prstGeom prst="ellipse">
             <a:avLst/>
@@ -4822,7 +4822,7 @@
         </p:blipFill>
         <p:spPr>
           <a:xfrm>
-            <a:off x="5120640" y="1600200"/>
+            <a:off x="5148072" y="1627632"/>
             <a:ext cx="365760" cy="365760"/>
           </a:xfrm>
           <a:prstGeom prst="rect">
@@ -4838,8 +4838,8 @@
         </p:nvSpPr>
         <p:spPr>
           <a:xfrm>
-            <a:off x="5806440" y="1325880"/>
-            <a:ext cx="2743200" cy="365760"/>
+            <a:off x="5806440" y="1371600"/>
+            <a:ext cx="2834640" cy="365760"/>
           </a:xfrm>
           <a:prstGeom prst="rect">
             <a:avLst/>
@@ -4877,8 +4877,8 @@
         </p:nvSpPr>
         <p:spPr>
           <a:xfrm>
-            <a:off x="5806440" y="1783080"/>
-            <a:ext cx="2743200" cy="594360"/>
+            <a:off x="5806440" y="1828800"/>
+            <a:ext cx="2834640" cy="548640"/>
           </a:xfrm>
           <a:prstGeom prst="rect">
             <a:avLst/>
@@ -4902,7 +4902,7 @@
                 <a:ea typeface="Calibri" pitchFamily="34" charset="-122"/>
                 <a:cs typeface="Calibri" pitchFamily="34" charset="-120"/>
               </a:rPr>
-              <a:t>选中页面元素与 AI 对话增量/全量修改，原生与工程模式双路径</a:t>
+              <a:t>选中元素与 AI 对话修改，支持原生与工程双模式</a:t>
             </a:r>
             <a:endParaRPr lang="en-US" sz="1300" dirty="0"/>
           </a:p>
@@ -4916,8 +4916,8 @@
         </p:nvSpPr>
         <p:spPr>
           <a:xfrm>
-            <a:off x="457200" y="2743200"/>
-            <a:ext cx="4023360" cy="1508760"/>
+            <a:off x="457200" y="2788920"/>
+            <a:ext cx="4069080" cy="1554480"/>
           </a:xfrm>
           <a:prstGeom prst="rect">
             <a:avLst/>
@@ -4943,8 +4943,8 @@
         </p:nvSpPr>
         <p:spPr>
           <a:xfrm>
-            <a:off x="685800" y="3154680"/>
-            <a:ext cx="640080" cy="640080"/>
+            <a:off x="685800" y="3246120"/>
+            <a:ext cx="594360" cy="594360"/>
           </a:xfrm>
           <a:prstGeom prst="ellipse">
             <a:avLst/>
@@ -4971,7 +4971,7 @@
         </p:blipFill>
         <p:spPr>
           <a:xfrm>
-            <a:off x="822960" y="3291840"/>
+            <a:off x="804672" y="3364992"/>
             <a:ext cx="365760" cy="365760"/>
           </a:xfrm>
           <a:prstGeom prst="rect">
@@ -4987,8 +4987,8 @@
         </p:nvSpPr>
         <p:spPr>
           <a:xfrm>
-            <a:off x="1508760" y="3017520"/>
-            <a:ext cx="2743200" cy="365760"/>
+            <a:off x="1463040" y="3108960"/>
+            <a:ext cx="2834640" cy="365760"/>
           </a:xfrm>
           <a:prstGeom prst="rect">
             <a:avLst/>
@@ -5026,8 +5026,8 @@
         </p:nvSpPr>
         <p:spPr>
           <a:xfrm>
-            <a:off x="1508760" y="3474720"/>
-            <a:ext cx="2743200" cy="594360"/>
+            <a:off x="1463040" y="3566160"/>
+            <a:ext cx="2834640" cy="548640"/>
           </a:xfrm>
           <a:prstGeom prst="rect">
             <a:avLst/>
@@ -5065,8 +5065,8 @@
         </p:nvSpPr>
         <p:spPr>
           <a:xfrm>
-            <a:off x="4754880" y="2743200"/>
-            <a:ext cx="4023360" cy="1508760"/>
+            <a:off x="4800600" y="2788920"/>
+            <a:ext cx="4069080" cy="1554480"/>
           </a:xfrm>
           <a:prstGeom prst="rect">
             <a:avLst/>
@@ -5092,8 +5092,8 @@
         </p:nvSpPr>
         <p:spPr>
           <a:xfrm>
-            <a:off x="4983480" y="3154680"/>
-            <a:ext cx="640080" cy="640080"/>
+            <a:off x="5029200" y="3246120"/>
+            <a:ext cx="594360" cy="594360"/>
           </a:xfrm>
           <a:prstGeom prst="ellipse">
             <a:avLst/>
@@ -5120,7 +5120,7 @@
         </p:blipFill>
         <p:spPr>
           <a:xfrm>
-            <a:off x="5120640" y="3291840"/>
+            <a:off x="5148072" y="3364992"/>
             <a:ext cx="365760" cy="365760"/>
           </a:xfrm>
           <a:prstGeom prst="rect">
@@ -5136,8 +5136,8 @@
         </p:nvSpPr>
         <p:spPr>
           <a:xfrm>
-            <a:off x="5806440" y="3017520"/>
-            <a:ext cx="2743200" cy="365760"/>
+            <a:off x="5806440" y="3108960"/>
+            <a:ext cx="2834640" cy="365760"/>
           </a:xfrm>
           <a:prstGeom prst="rect">
             <a:avLst/>
@@ -5175,8 +5175,8 @@
         </p:nvSpPr>
         <p:spPr>
           <a:xfrm>
-            <a:off x="5806440" y="3474720"/>
-            <a:ext cx="2743200" cy="594360"/>
+            <a:off x="5806440" y="3566160"/>
+            <a:ext cx="2834640" cy="548640"/>
           </a:xfrm>
           <a:prstGeom prst="rect">
             <a:avLst/>
@@ -5200,7 +5200,7 @@
                 <a:ea typeface="Calibri" pitchFamily="34" charset="-122"/>
                 <a:cs typeface="Calibri" pitchFamily="34" charset="-120"/>
               </a:rPr>
-              <a:t>用户/应用管理、精选案例、AI 调用与系统性能监控</a:t>
+              <a:t>用户/应用管理、精选案例、AI 调用与性能监控</a:t>
             </a:r>
             <a:endParaRPr lang="en-US" sz="1300" dirty="0"/>
           </a:p>
@@ -5214,7 +5214,7 @@
         </p:nvSpPr>
         <p:spPr>
           <a:xfrm>
-            <a:off x="457200" y="4800600"/>
+            <a:off x="457200" y="4828032"/>
             <a:ext cx="8229600" cy="228600"/>
           </a:xfrm>
           <a:prstGeom prst="rect">
@@ -5231,9 +5231,9 @@
               <a:buNone/>
             </a:pPr>
             <a:r>
-              <a:rPr lang="en-US" sz="1000" dirty="0">
-                <a:solidFill>
-                  <a:srgbClr val="64748B"/>
+              <a:rPr lang="en-US" sz="1100" dirty="0">
+                <a:solidFill>
+                  <a:srgbClr val="475569"/>
                 </a:solidFill>
                 <a:latin typeface="Calibri" pitchFamily="34" charset="0"/>
                 <a:ea typeface="Calibri" pitchFamily="34" charset="-122"/>
@@ -5241,7 +5241,7 @@
               </a:rPr>
               <a:t>yu-ai-code-mother  ·  每日项目状态  ·  2026-08-05</a:t>
             </a:r>
-            <a:endParaRPr lang="en-US" sz="1000" dirty="0"/>
+            <a:endParaRPr lang="en-US" sz="1100" dirty="0"/>
           </a:p>
         </p:txBody>
       </p:sp>
@@ -5725,7 +5725,7 @@
         </p:nvSpPr>
         <p:spPr>
           <a:xfrm>
-            <a:off x="3337560" y="1051560"/>
+            <a:off x="3383280" y="1051560"/>
             <a:ext cx="2743200" cy="3383280"/>
           </a:xfrm>
           <a:prstGeom prst="rect">
@@ -5752,7 +5752,7 @@
         </p:nvSpPr>
         <p:spPr>
           <a:xfrm>
-            <a:off x="3337560" y="1051560"/>
+            <a:off x="3383280" y="1051560"/>
             <a:ext cx="2743200" cy="548640"/>
           </a:xfrm>
           <a:prstGeom prst="rect">
@@ -5772,7 +5772,7 @@
         </p:nvSpPr>
         <p:spPr>
           <a:xfrm>
-            <a:off x="3337560" y="1051560"/>
+            <a:off x="3383280" y="1051560"/>
             <a:ext cx="2743200" cy="548640"/>
           </a:xfrm>
           <a:prstGeom prst="rect">
@@ -5811,7 +5811,7 @@
         </p:nvSpPr>
         <p:spPr>
           <a:xfrm>
-            <a:off x="3566160" y="1920240"/>
+            <a:off x="3611880" y="1920240"/>
             <a:ext cx="146304" cy="146304"/>
           </a:xfrm>
           <a:prstGeom prst="ellipse">
@@ -5831,7 +5831,7 @@
         </p:nvSpPr>
         <p:spPr>
           <a:xfrm>
-            <a:off x="3840480" y="1828800"/>
+            <a:off x="3886200" y="1828800"/>
             <a:ext cx="2057400" cy="365760"/>
           </a:xfrm>
           <a:prstGeom prst="rect">
@@ -5870,7 +5870,7 @@
         </p:nvSpPr>
         <p:spPr>
           <a:xfrm>
-            <a:off x="3566160" y="2377440"/>
+            <a:off x="3611880" y="2377440"/>
             <a:ext cx="146304" cy="146304"/>
           </a:xfrm>
           <a:prstGeom prst="ellipse">
@@ -5890,7 +5890,7 @@
         </p:nvSpPr>
         <p:spPr>
           <a:xfrm>
-            <a:off x="3840480" y="2286000"/>
+            <a:off x="3886200" y="2286000"/>
             <a:ext cx="2057400" cy="365760"/>
           </a:xfrm>
           <a:prstGeom prst="rect">
@@ -5929,7 +5929,7 @@
         </p:nvSpPr>
         <p:spPr>
           <a:xfrm>
-            <a:off x="3566160" y="2834640"/>
+            <a:off x="3611880" y="2834640"/>
             <a:ext cx="146304" cy="146304"/>
           </a:xfrm>
           <a:prstGeom prst="ellipse">
@@ -5949,7 +5949,7 @@
         </p:nvSpPr>
         <p:spPr>
           <a:xfrm>
-            <a:off x="3840480" y="2743200"/>
+            <a:off x="3886200" y="2743200"/>
             <a:ext cx="2057400" cy="365760"/>
           </a:xfrm>
           <a:prstGeom prst="rect">
@@ -5988,7 +5988,7 @@
         </p:nvSpPr>
         <p:spPr>
           <a:xfrm>
-            <a:off x="3566160" y="3291840"/>
+            <a:off x="3611880" y="3291840"/>
             <a:ext cx="146304" cy="146304"/>
           </a:xfrm>
           <a:prstGeom prst="ellipse">
@@ -6008,7 +6008,7 @@
         </p:nvSpPr>
         <p:spPr>
           <a:xfrm>
-            <a:off x="3840480" y="3200400"/>
+            <a:off x="3886200" y="3200400"/>
             <a:ext cx="2057400" cy="365760"/>
           </a:xfrm>
           <a:prstGeom prst="rect">
@@ -6047,7 +6047,7 @@
         </p:nvSpPr>
         <p:spPr>
           <a:xfrm>
-            <a:off x="3566160" y="3749040"/>
+            <a:off x="3611880" y="3749040"/>
             <a:ext cx="146304" cy="146304"/>
           </a:xfrm>
           <a:prstGeom prst="ellipse">
@@ -6067,7 +6067,7 @@
         </p:nvSpPr>
         <p:spPr>
           <a:xfrm>
-            <a:off x="3840480" y="3657600"/>
+            <a:off x="3886200" y="3657600"/>
             <a:ext cx="2057400" cy="365760"/>
           </a:xfrm>
           <a:prstGeom prst="rect">
@@ -6106,7 +6106,7 @@
         </p:nvSpPr>
         <p:spPr>
           <a:xfrm>
-            <a:off x="6217920" y="1051560"/>
+            <a:off x="6309360" y="1051560"/>
             <a:ext cx="2743200" cy="3383280"/>
           </a:xfrm>
           <a:prstGeom prst="rect">
@@ -6133,7 +6133,7 @@
         </p:nvSpPr>
         <p:spPr>
           <a:xfrm>
-            <a:off x="6217920" y="1051560"/>
+            <a:off x="6309360" y="1051560"/>
             <a:ext cx="2743200" cy="548640"/>
           </a:xfrm>
           <a:prstGeom prst="rect">
@@ -6153,7 +6153,7 @@
         </p:nvSpPr>
         <p:spPr>
           <a:xfrm>
-            <a:off x="6217920" y="1051560"/>
+            <a:off x="6309360" y="1051560"/>
             <a:ext cx="2743200" cy="548640"/>
           </a:xfrm>
           <a:prstGeom prst="rect">
@@ -6192,7 +6192,7 @@
         </p:nvSpPr>
         <p:spPr>
           <a:xfrm>
-            <a:off x="6446520" y="1920240"/>
+            <a:off x="6537960" y="1920240"/>
             <a:ext cx="146304" cy="146304"/>
           </a:xfrm>
           <a:prstGeom prst="ellipse">
@@ -6212,7 +6212,7 @@
         </p:nvSpPr>
         <p:spPr>
           <a:xfrm>
-            <a:off x="6720840" y="1828800"/>
+            <a:off x="6812280" y="1828800"/>
             <a:ext cx="2057400" cy="365760"/>
           </a:xfrm>
           <a:prstGeom prst="rect">
@@ -6237,7 +6237,7 @@
                 <a:ea typeface="Calibri" pitchFamily="34" charset="-122"/>
                 <a:cs typeface="Calibri" pitchFamily="34" charset="-120"/>
               </a:rPr>
-              <a:t>pages：home / app / admin</a:t>
+              <a:t>home / app / admin 页</a:t>
             </a:r>
             <a:endParaRPr lang="en-US" sz="1300" dirty="0"/>
           </a:p>
@@ -6251,7 +6251,7 @@
         </p:nvSpPr>
         <p:spPr>
           <a:xfrm>
-            <a:off x="6446520" y="2377440"/>
+            <a:off x="6537960" y="2377440"/>
             <a:ext cx="146304" cy="146304"/>
           </a:xfrm>
           <a:prstGeom prst="ellipse">
@@ -6271,7 +6271,7 @@
         </p:nvSpPr>
         <p:spPr>
           <a:xfrm>
-            <a:off x="6720840" y="2286000"/>
+            <a:off x="6812280" y="2286000"/>
             <a:ext cx="2057400" cy="365760"/>
           </a:xfrm>
           <a:prstGeom prst="rect">
@@ -6310,7 +6310,7 @@
         </p:nvSpPr>
         <p:spPr>
           <a:xfrm>
-            <a:off x="6446520" y="2834640"/>
+            <a:off x="6537960" y="2834640"/>
             <a:ext cx="146304" cy="146304"/>
           </a:xfrm>
           <a:prstGeom prst="ellipse">
@@ -6330,7 +6330,7 @@
         </p:nvSpPr>
         <p:spPr>
           <a:xfrm>
-            <a:off x="6720840" y="2743200"/>
+            <a:off x="6812280" y="2743200"/>
             <a:ext cx="2057400" cy="365760"/>
           </a:xfrm>
           <a:prstGeom prst="rect">
@@ -6369,7 +6369,7 @@
         </p:nvSpPr>
         <p:spPr>
           <a:xfrm>
-            <a:off x="6446520" y="3291840"/>
+            <a:off x="6537960" y="3291840"/>
             <a:ext cx="146304" cy="146304"/>
           </a:xfrm>
           <a:prstGeom prst="ellipse">
@@ -6389,7 +6389,7 @@
         </p:nvSpPr>
         <p:spPr>
           <a:xfrm>
-            <a:off x="6720840" y="3200400"/>
+            <a:off x="6812280" y="3200400"/>
             <a:ext cx="2057400" cy="365760"/>
           </a:xfrm>
           <a:prstGeom prst="rect">
@@ -6428,7 +6428,7 @@
         </p:nvSpPr>
         <p:spPr>
           <a:xfrm>
-            <a:off x="6446520" y="3749040"/>
+            <a:off x="6537960" y="3749040"/>
             <a:ext cx="146304" cy="146304"/>
           </a:xfrm>
           <a:prstGeom prst="ellipse">
@@ -6448,7 +6448,7 @@
         </p:nvSpPr>
         <p:spPr>
           <a:xfrm>
-            <a:off x="6720840" y="3657600"/>
+            <a:off x="6812280" y="3657600"/>
             <a:ext cx="2057400" cy="365760"/>
           </a:xfrm>
           <a:prstGeom prst="rect">
@@ -6487,7 +6487,7 @@
         </p:nvSpPr>
         <p:spPr>
           <a:xfrm>
-            <a:off x="457200" y="4800600"/>
+            <a:off x="457200" y="4828032"/>
             <a:ext cx="8229600" cy="228600"/>
           </a:xfrm>
           <a:prstGeom prst="rect">
@@ -6504,9 +6504,9 @@
               <a:buNone/>
             </a:pPr>
             <a:r>
-              <a:rPr lang="en-US" sz="1000" dirty="0">
-                <a:solidFill>
-                  <a:srgbClr val="64748B"/>
+              <a:rPr lang="en-US" sz="1100" dirty="0">
+                <a:solidFill>
+                  <a:srgbClr val="475569"/>
                 </a:solidFill>
                 <a:latin typeface="Calibri" pitchFamily="34" charset="0"/>
                 <a:ea typeface="Calibri" pitchFamily="34" charset="-122"/>
@@ -6514,7 +6514,7 @@
               </a:rPr>
               <a:t>yu-ai-code-mother  ·  每日项目状态  ·  2026-08-05</a:t>
             </a:r>
-            <a:endParaRPr lang="en-US" sz="1000" dirty="0"/>
+            <a:endParaRPr lang="en-US" sz="1100" dirty="0"/>
           </a:p>
         </p:txBody>
       </p:sp>
@@ -6656,8 +6656,8 @@
         </p:nvSpPr>
         <p:spPr>
           <a:xfrm>
-            <a:off x="457200" y="1463040"/>
-            <a:ext cx="4023360" cy="1280160"/>
+            <a:off x="457200" y="1417320"/>
+            <a:ext cx="4069080" cy="1280160"/>
           </a:xfrm>
           <a:prstGeom prst="rect">
             <a:avLst/>
@@ -6683,7 +6683,7 @@
         </p:nvSpPr>
         <p:spPr>
           <a:xfrm>
-            <a:off x="457200" y="1463040"/>
+            <a:off x="457200" y="1417320"/>
             <a:ext cx="109728" cy="1280160"/>
           </a:xfrm>
           <a:prstGeom prst="rect">
@@ -6703,7 +6703,7 @@
         </p:nvSpPr>
         <p:spPr>
           <a:xfrm>
-            <a:off x="777240" y="1645920"/>
+            <a:off x="777240" y="1600200"/>
             <a:ext cx="777240" cy="292608"/>
           </a:xfrm>
           <a:prstGeom prst="roundRect">
@@ -6725,7 +6725,7 @@
         </p:nvSpPr>
         <p:spPr>
           <a:xfrm>
-            <a:off x="777240" y="1645920"/>
+            <a:off x="777240" y="1600200"/>
             <a:ext cx="777240" cy="292608"/>
           </a:xfrm>
           <a:prstGeom prst="rect">
@@ -6764,8 +6764,8 @@
         </p:nvSpPr>
         <p:spPr>
           <a:xfrm>
-            <a:off x="777240" y="2011680"/>
-            <a:ext cx="3474720" cy="320040"/>
+            <a:off x="777240" y="1965960"/>
+            <a:ext cx="3520440" cy="320040"/>
           </a:xfrm>
           <a:prstGeom prst="rect">
             <a:avLst/>
@@ -6803,8 +6803,8 @@
         </p:nvSpPr>
         <p:spPr>
           <a:xfrm>
-            <a:off x="777240" y="2331720"/>
-            <a:ext cx="3474720" cy="274320"/>
+            <a:off x="777240" y="2286000"/>
+            <a:ext cx="3520440" cy="274320"/>
           </a:xfrm>
           <a:prstGeom prst="rect">
             <a:avLst/>
@@ -6828,7 +6828,7 @@
                 <a:ea typeface="Calibri" pitchFamily="34" charset="-122"/>
                 <a:cs typeface="Calibri" pitchFamily="34" charset="-120"/>
               </a:rPr>
-              <a:t>微服务收官（893918c），单体与 7 模块并存</a:t>
+              <a:t>微服务收官 893918c，单体与 7 模块并存</a:t>
             </a:r>
             <a:endParaRPr lang="en-US" sz="1200" dirty="0"/>
           </a:p>
@@ -6842,8 +6842,8 @@
         </p:nvSpPr>
         <p:spPr>
           <a:xfrm>
-            <a:off x="4754880" y="1463040"/>
-            <a:ext cx="4023360" cy="1280160"/>
+            <a:off x="4800600" y="1417320"/>
+            <a:ext cx="4069080" cy="1280160"/>
           </a:xfrm>
           <a:prstGeom prst="rect">
             <a:avLst/>
@@ -6869,7 +6869,7 @@
         </p:nvSpPr>
         <p:spPr>
           <a:xfrm>
-            <a:off x="4754880" y="1463040"/>
+            <a:off x="4800600" y="1417320"/>
             <a:ext cx="109728" cy="1280160"/>
           </a:xfrm>
           <a:prstGeom prst="rect">
@@ -6889,7 +6889,7 @@
         </p:nvSpPr>
         <p:spPr>
           <a:xfrm>
-            <a:off x="5074920" y="1645920"/>
+            <a:off x="5120640" y="1600200"/>
             <a:ext cx="777240" cy="292608"/>
           </a:xfrm>
           <a:prstGeom prst="roundRect">
@@ -6911,7 +6911,7 @@
         </p:nvSpPr>
         <p:spPr>
           <a:xfrm>
-            <a:off x="5074920" y="1645920"/>
+            <a:off x="5120640" y="1600200"/>
             <a:ext cx="777240" cy="292608"/>
           </a:xfrm>
           <a:prstGeom prst="rect">
@@ -6950,8 +6950,8 @@
         </p:nvSpPr>
         <p:spPr>
           <a:xfrm>
-            <a:off x="5074920" y="2011680"/>
-            <a:ext cx="3474720" cy="320040"/>
+            <a:off x="5120640" y="1965960"/>
+            <a:ext cx="3520440" cy="320040"/>
           </a:xfrm>
           <a:prstGeom prst="rect">
             <a:avLst/>
@@ -6989,8 +6989,8 @@
         </p:nvSpPr>
         <p:spPr>
           <a:xfrm>
-            <a:off x="5074920" y="2331720"/>
-            <a:ext cx="3474720" cy="274320"/>
+            <a:off x="5120640" y="2286000"/>
+            <a:ext cx="3520440" cy="274320"/>
           </a:xfrm>
           <a:prstGeom prst="rect">
             <a:avLst/>
@@ -7014,7 +7014,7 @@
                 <a:ea typeface="Calibri" pitchFamily="34" charset="-122"/>
                 <a:cs typeface="Calibri" pitchFamily="34" charset="-120"/>
               </a:rPr>
-              <a:t>PR #66 + Issue #65：联网搜索工具，未合入</a:t>
+              <a:t>PR #66 与 Issue #65：联网搜索工具未合入</a:t>
             </a:r>
             <a:endParaRPr lang="en-US" sz="1200" dirty="0"/>
           </a:p>
@@ -7029,7 +7029,7 @@
         <p:spPr>
           <a:xfrm>
             <a:off x="457200" y="2880360"/>
-            <a:ext cx="4023360" cy="1280160"/>
+            <a:ext cx="4069080" cy="1280160"/>
           </a:xfrm>
           <a:prstGeom prst="rect">
             <a:avLst/>
@@ -7137,7 +7137,7 @@
         <p:spPr>
           <a:xfrm>
             <a:off x="777240" y="3429000"/>
-            <a:ext cx="3474720" cy="320040"/>
+            <a:ext cx="3520440" cy="320040"/>
           </a:xfrm>
           <a:prstGeom prst="rect">
             <a:avLst/>
@@ -7176,7 +7176,7 @@
         <p:spPr>
           <a:xfrm>
             <a:off x="777240" y="3749040"/>
-            <a:ext cx="3474720" cy="274320"/>
+            <a:ext cx="3520440" cy="274320"/>
           </a:xfrm>
           <a:prstGeom prst="rect">
             <a:avLst/>
@@ -7200,7 +7200,7 @@
                 <a:ea typeface="Calibri" pitchFamily="34" charset="-122"/>
                 <a:cs typeface="Calibri" pitchFamily="34" charset="-120"/>
               </a:rPr>
-              <a:t>Issue #5：缺 reasoning_content，社区仍有反馈</a:t>
+              <a:t>Issue #5 缺 reasoning_content，社区仍有反馈</a:t>
             </a:r>
             <a:endParaRPr lang="en-US" sz="1200" dirty="0"/>
           </a:p>
@@ -7214,8 +7214,8 @@
         </p:nvSpPr>
         <p:spPr>
           <a:xfrm>
-            <a:off x="4754880" y="2880360"/>
-            <a:ext cx="4023360" cy="1280160"/>
+            <a:off x="4800600" y="2880360"/>
+            <a:ext cx="4069080" cy="1280160"/>
           </a:xfrm>
           <a:prstGeom prst="rect">
             <a:avLst/>
@@ -7241,7 +7241,7 @@
         </p:nvSpPr>
         <p:spPr>
           <a:xfrm>
-            <a:off x="4754880" y="2880360"/>
+            <a:off x="4800600" y="2880360"/>
             <a:ext cx="109728" cy="1280160"/>
           </a:xfrm>
           <a:prstGeom prst="rect">
@@ -7261,7 +7261,7 @@
         </p:nvSpPr>
         <p:spPr>
           <a:xfrm>
-            <a:off x="5074920" y="3063240"/>
+            <a:off x="5120640" y="3063240"/>
             <a:ext cx="777240" cy="292608"/>
           </a:xfrm>
           <a:prstGeom prst="roundRect">
@@ -7283,7 +7283,7 @@
         </p:nvSpPr>
         <p:spPr>
           <a:xfrm>
-            <a:off x="5074920" y="3063240"/>
+            <a:off x="5120640" y="3063240"/>
             <a:ext cx="777240" cy="292608"/>
           </a:xfrm>
           <a:prstGeom prst="rect">
@@ -7322,8 +7322,8 @@
         </p:nvSpPr>
         <p:spPr>
           <a:xfrm>
-            <a:off x="5074920" y="3429000"/>
-            <a:ext cx="3474720" cy="320040"/>
+            <a:off x="5120640" y="3429000"/>
+            <a:ext cx="3520440" cy="320040"/>
           </a:xfrm>
           <a:prstGeom prst="rect">
             <a:avLst/>
@@ -7361,8 +7361,8 @@
         </p:nvSpPr>
         <p:spPr>
           <a:xfrm>
-            <a:off x="5074920" y="3749040"/>
-            <a:ext cx="3474720" cy="274320"/>
+            <a:off x="5120640" y="3749040"/>
+            <a:ext cx="3520440" cy="274320"/>
           </a:xfrm>
           <a:prstGeom prst="rect">
             <a:avLst/>
@@ -7400,7 +7400,7 @@
         </p:nvSpPr>
         <p:spPr>
           <a:xfrm>
-            <a:off x="457200" y="4800600"/>
+            <a:off x="457200" y="4828032"/>
             <a:ext cx="8229600" cy="228600"/>
           </a:xfrm>
           <a:prstGeom prst="rect">
@@ -7417,9 +7417,9 @@
               <a:buNone/>
             </a:pPr>
             <a:r>
-              <a:rPr lang="en-US" sz="1000" dirty="0">
-                <a:solidFill>
-                  <a:srgbClr val="64748B"/>
+              <a:rPr lang="en-US" sz="1100" dirty="0">
+                <a:solidFill>
+                  <a:srgbClr val="475569"/>
                 </a:solidFill>
                 <a:latin typeface="Calibri" pitchFamily="34" charset="0"/>
                 <a:ea typeface="Calibri" pitchFamily="34" charset="-122"/>
@@ -7427,7 +7427,7 @@
               </a:rPr>
               <a:t>yu-ai-code-mother  ·  每日项目状态  ·  2026-08-05</a:t>
             </a:r>
-            <a:endParaRPr lang="en-US" sz="1000" dirty="0"/>
+            <a:endParaRPr lang="en-US" sz="1100" dirty="0"/>
           </a:p>
         </p:txBody>
       </p:sp>
@@ -7549,13 +7549,13 @@
             <a:r>
               <a:rPr lang="en-US" sz="1300" i="1" dirty="0">
                 <a:solidFill>
-                  <a:srgbClr val="64748B"/>
+                  <a:srgbClr val="475569"/>
                 </a:solidFill>
                 <a:latin typeface="Calibri" pitchFamily="34" charset="0"/>
                 <a:ea typeface="Calibri" pitchFamily="34" charset="-122"/>
                 <a:cs typeface="Calibri" pitchFamily="34" charset="-120"/>
               </a:rPr>
-              <a:t>以下为仓库静态盘点与可观测性配置摘要；运行时业务指标待接入生产数据后填充。</a:t>
+              <a:t>以下为仓库静态盘点与可观测性配置摘要；运行时 KPI 依赖生产抓取，本页以仓库元数据为准。</a:t>
             </a:r>
             <a:endParaRPr lang="en-US" sz="1300" dirty="0"/>
           </a:p>
@@ -7570,7 +7570,7 @@
         <p:spPr>
           <a:xfrm>
             <a:off x="457200" y="1417320"/>
-            <a:ext cx="2011680" cy="2194560"/>
+            <a:ext cx="2011680" cy="2103120"/>
           </a:xfrm>
           <a:prstGeom prst="rect">
             <a:avLst/>
@@ -7616,8 +7616,8 @@
         </p:nvSpPr>
         <p:spPr>
           <a:xfrm>
-            <a:off x="457200" y="1691640"/>
-            <a:ext cx="2011680" cy="731520"/>
+            <a:off x="457200" y="1645920"/>
+            <a:ext cx="2011680" cy="685800"/>
           </a:xfrm>
           <a:prstGeom prst="rect">
             <a:avLst/>
@@ -7655,7 +7655,7 @@
         </p:nvSpPr>
         <p:spPr>
           <a:xfrm>
-            <a:off x="457200" y="2377440"/>
+            <a:off x="457200" y="2331720"/>
             <a:ext cx="2011680" cy="228600"/>
           </a:xfrm>
           <a:prstGeom prst="rect">
@@ -7694,7 +7694,7 @@
         </p:nvSpPr>
         <p:spPr>
           <a:xfrm>
-            <a:off x="548640" y="2743200"/>
+            <a:off x="548640" y="2697480"/>
             <a:ext cx="1828800" cy="320040"/>
           </a:xfrm>
           <a:prstGeom prst="rect">
@@ -7733,8 +7733,8 @@
         </p:nvSpPr>
         <p:spPr>
           <a:xfrm>
-            <a:off x="548640" y="3108960"/>
-            <a:ext cx="1828800" cy="320040"/>
+            <a:off x="548640" y="3063240"/>
+            <a:ext cx="1828800" cy="274320"/>
           </a:xfrm>
           <a:prstGeom prst="rect">
             <a:avLst/>
@@ -7752,7 +7752,7 @@
             <a:r>
               <a:rPr lang="en-US" sz="1100" dirty="0">
                 <a:solidFill>
-                  <a:srgbClr val="64748B"/>
+                  <a:srgbClr val="475569"/>
                 </a:solidFill>
                 <a:latin typeface="Calibri" pitchFamily="34" charset="0"/>
                 <a:ea typeface="Calibri" pitchFamily="34" charset="-122"/>
@@ -7772,8 +7772,8 @@
         </p:nvSpPr>
         <p:spPr>
           <a:xfrm>
-            <a:off x="2606040" y="1417320"/>
-            <a:ext cx="2011680" cy="2194560"/>
+            <a:off x="2628900" y="1417320"/>
+            <a:ext cx="2011680" cy="2103120"/>
           </a:xfrm>
           <a:prstGeom prst="rect">
             <a:avLst/>
@@ -7799,7 +7799,7 @@
         </p:nvSpPr>
         <p:spPr>
           <a:xfrm>
-            <a:off x="2606040" y="1417320"/>
+            <a:off x="2628900" y="1417320"/>
             <a:ext cx="2011680" cy="91440"/>
           </a:xfrm>
           <a:prstGeom prst="rect">
@@ -7819,8 +7819,8 @@
         </p:nvSpPr>
         <p:spPr>
           <a:xfrm>
-            <a:off x="2606040" y="1691640"/>
-            <a:ext cx="2011680" cy="731520"/>
+            <a:off x="2628900" y="1645920"/>
+            <a:ext cx="2011680" cy="685800"/>
           </a:xfrm>
           <a:prstGeom prst="rect">
             <a:avLst/>
@@ -7858,7 +7858,7 @@
         </p:nvSpPr>
         <p:spPr>
           <a:xfrm>
-            <a:off x="2606040" y="2377440"/>
+            <a:off x="2628900" y="2331720"/>
             <a:ext cx="2011680" cy="228600"/>
           </a:xfrm>
           <a:prstGeom prst="rect">
@@ -7897,7 +7897,7 @@
         </p:nvSpPr>
         <p:spPr>
           <a:xfrm>
-            <a:off x="2697480" y="2743200"/>
+            <a:off x="2720340" y="2697480"/>
             <a:ext cx="1828800" cy="320040"/>
           </a:xfrm>
           <a:prstGeom prst="rect">
@@ -7936,8 +7936,8 @@
         </p:nvSpPr>
         <p:spPr>
           <a:xfrm>
-            <a:off x="2697480" y="3108960"/>
-            <a:ext cx="1828800" cy="320040"/>
+            <a:off x="2720340" y="3063240"/>
+            <a:ext cx="1828800" cy="274320"/>
           </a:xfrm>
           <a:prstGeom prst="rect">
             <a:avLst/>
@@ -7955,7 +7955,7 @@
             <a:r>
               <a:rPr lang="en-US" sz="1100" dirty="0">
                 <a:solidFill>
-                  <a:srgbClr val="64748B"/>
+                  <a:srgbClr val="475569"/>
                 </a:solidFill>
                 <a:latin typeface="Calibri" pitchFamily="34" charset="0"/>
                 <a:ea typeface="Calibri" pitchFamily="34" charset="-122"/>
@@ -7975,8 +7975,8 @@
         </p:nvSpPr>
         <p:spPr>
           <a:xfrm>
-            <a:off x="4754880" y="1417320"/>
-            <a:ext cx="2011680" cy="2194560"/>
+            <a:off x="4800600" y="1417320"/>
+            <a:ext cx="2011680" cy="2103120"/>
           </a:xfrm>
           <a:prstGeom prst="rect">
             <a:avLst/>
@@ -8002,7 +8002,7 @@
         </p:nvSpPr>
         <p:spPr>
           <a:xfrm>
-            <a:off x="4754880" y="1417320"/>
+            <a:off x="4800600" y="1417320"/>
             <a:ext cx="2011680" cy="91440"/>
           </a:xfrm>
           <a:prstGeom prst="rect">
@@ -8022,8 +8022,8 @@
         </p:nvSpPr>
         <p:spPr>
           <a:xfrm>
-            <a:off x="4754880" y="1691640"/>
-            <a:ext cx="2011680" cy="731520"/>
+            <a:off x="4800600" y="1645920"/>
+            <a:ext cx="2011680" cy="685800"/>
           </a:xfrm>
           <a:prstGeom prst="rect">
             <a:avLst/>
@@ -8061,7 +8061,7 @@
         </p:nvSpPr>
         <p:spPr>
           <a:xfrm>
-            <a:off x="4754880" y="2377440"/>
+            <a:off x="4800600" y="2331720"/>
             <a:ext cx="2011680" cy="228600"/>
           </a:xfrm>
           <a:prstGeom prst="rect">
@@ -8100,7 +8100,7 @@
         </p:nvSpPr>
         <p:spPr>
           <a:xfrm>
-            <a:off x="4846320" y="2743200"/>
+            <a:off x="4892040" y="2697480"/>
             <a:ext cx="1828800" cy="320040"/>
           </a:xfrm>
           <a:prstGeom prst="rect">
@@ -8139,8 +8139,8 @@
         </p:nvSpPr>
         <p:spPr>
           <a:xfrm>
-            <a:off x="4846320" y="3108960"/>
-            <a:ext cx="1828800" cy="320040"/>
+            <a:off x="4892040" y="3063240"/>
+            <a:ext cx="1828800" cy="274320"/>
           </a:xfrm>
           <a:prstGeom prst="rect">
             <a:avLst/>
@@ -8158,7 +8158,7 @@
             <a:r>
               <a:rPr lang="en-US" sz="1100" dirty="0">
                 <a:solidFill>
-                  <a:srgbClr val="64748B"/>
+                  <a:srgbClr val="475569"/>
                 </a:solidFill>
                 <a:latin typeface="Calibri" pitchFamily="34" charset="0"/>
                 <a:ea typeface="Calibri" pitchFamily="34" charset="-122"/>
@@ -8178,8 +8178,8 @@
         </p:nvSpPr>
         <p:spPr>
           <a:xfrm>
-            <a:off x="6903720" y="1417320"/>
-            <a:ext cx="2011680" cy="2194560"/>
+            <a:off x="6972300" y="1417320"/>
+            <a:ext cx="2011680" cy="2103120"/>
           </a:xfrm>
           <a:prstGeom prst="rect">
             <a:avLst/>
@@ -8205,7 +8205,7 @@
         </p:nvSpPr>
         <p:spPr>
           <a:xfrm>
-            <a:off x="6903720" y="1417320"/>
+            <a:off x="6972300" y="1417320"/>
             <a:ext cx="2011680" cy="91440"/>
           </a:xfrm>
           <a:prstGeom prst="rect">
@@ -8225,8 +8225,8 @@
         </p:nvSpPr>
         <p:spPr>
           <a:xfrm>
-            <a:off x="6903720" y="1691640"/>
-            <a:ext cx="2011680" cy="731520"/>
+            <a:off x="6972300" y="1645920"/>
+            <a:ext cx="2011680" cy="685800"/>
           </a:xfrm>
           <a:prstGeom prst="rect">
             <a:avLst/>
@@ -8250,7 +8250,7 @@
                 <a:ea typeface="Georgia" pitchFamily="34" charset="-122"/>
                 <a:cs typeface="Georgia" pitchFamily="34" charset="-120"/>
               </a:rPr>
-              <a:t>15s</a:t>
+              <a:t>10</a:t>
             </a:r>
             <a:endParaRPr lang="en-US" sz="4000" dirty="0"/>
           </a:p>
@@ -8264,8 +8264,8 @@
         </p:nvSpPr>
         <p:spPr>
           <a:xfrm>
-            <a:off x="6995160" y="2743200"/>
-            <a:ext cx="1828800" cy="320040"/>
+            <a:off x="6972300" y="2331720"/>
+            <a:ext cx="2011680" cy="228600"/>
           </a:xfrm>
           <a:prstGeom prst="rect">
             <a:avLst/>
@@ -8281,17 +8281,17 @@
               <a:buNone/>
             </a:pPr>
             <a:r>
-              <a:rPr lang="en-US" sz="1300" b="1" dirty="0">
-                <a:solidFill>
-                  <a:srgbClr val="0A3D4A"/>
+              <a:rPr lang="en-US" sz="1200" dirty="0">
+                <a:solidFill>
+                  <a:srgbClr val="00A896"/>
                 </a:solidFill>
                 <a:latin typeface="Calibri" pitchFamily="34" charset="0"/>
                 <a:ea typeface="Calibri" pitchFamily="34" charset="-122"/>
                 <a:cs typeface="Calibri" pitchFamily="34" charset="-120"/>
               </a:rPr>
-              <a:t>抓取间隔（全局）</a:t>
-            </a:r>
-            <a:endParaRPr lang="en-US" sz="1300" dirty="0"/>
+              <a:t>秒</a:t>
+            </a:r>
+            <a:endParaRPr lang="en-US" sz="1200" dirty="0"/>
           </a:p>
         </p:txBody>
       </p:sp>
@@ -8303,7 +8303,7 @@
         </p:nvSpPr>
         <p:spPr>
           <a:xfrm>
-            <a:off x="6995160" y="3108960"/>
+            <a:off x="7063740" y="2697480"/>
             <a:ext cx="1828800" cy="320040"/>
           </a:xfrm>
           <a:prstGeom prst="rect">
@@ -8320,78 +8320,78 @@
               <a:buNone/>
             </a:pPr>
             <a:r>
-              <a:rPr lang="en-US" sz="1100" dirty="0">
-                <a:solidFill>
-                  <a:srgbClr val="64748B"/>
+              <a:rPr lang="en-US" sz="1300" b="1" dirty="0">
+                <a:solidFill>
+                  <a:srgbClr val="0A3D4A"/>
                 </a:solidFill>
                 <a:latin typeface="Calibri" pitchFamily="34" charset="0"/>
                 <a:ea typeface="Calibri" pitchFamily="34" charset="-122"/>
                 <a:cs typeface="Calibri" pitchFamily="34" charset="-120"/>
               </a:rPr>
-              <a:t>应用抓取 10s</a:t>
-            </a:r>
-            <a:endParaRPr lang="en-US" sz="1100" dirty="0"/>
-          </a:p>
-        </p:txBody>
-      </p:sp>
-      <p:sp>
-        <p:nvSpPr>
-          <p:cNvPr id="28" name="Shape 26"/>
-          <p:cNvSpPr/>
-          <p:nvPr/>
-        </p:nvSpPr>
-        <p:spPr>
-          <a:xfrm>
-            <a:off x="457200" y="3794760"/>
-            <a:ext cx="8229600" cy="731520"/>
-          </a:xfrm>
-          <a:prstGeom prst="rect">
-            <a:avLst/>
-          </a:prstGeom>
-          <a:solidFill>
-            <a:srgbClr val="E6F7F4"/>
-          </a:solidFill>
-          <a:ln/>
-        </p:spPr>
-      </p:sp>
-      <p:sp>
-        <p:nvSpPr>
-          <p:cNvPr id="29" name="Text 27"/>
-          <p:cNvSpPr/>
-          <p:nvPr/>
-        </p:nvSpPr>
-        <p:spPr>
-          <a:xfrm>
-            <a:off x="640080" y="3886200"/>
-            <a:ext cx="7863840" cy="548640"/>
-          </a:xfrm>
-          <a:prstGeom prst="rect">
-            <a:avLst/>
-          </a:prstGeom>
-          <a:noFill/>
-          <a:ln/>
-        </p:spPr>
-        <p:txBody>
-          <a:bodyPr wrap="square" lIns="0" tIns="0" rIns="0" bIns="0" rtlCol="0" anchor="ctr"/>
-          <a:lstStyle/>
-          <a:p>
-            <a:pPr indent="0" marL="0">
-              <a:buNone/>
-            </a:pPr>
-            <a:r>
-              <a:rPr lang="en-US" sz="1200" dirty="0">
-                <a:solidFill>
-                  <a:srgbClr val="334155"/>
+              <a:t>应用抓取间隔</a:t>
+            </a:r>
+            <a:endParaRPr lang="en-US" sz="1300" dirty="0"/>
+          </a:p>
+        </p:txBody>
+      </p:sp>
+      <p:sp>
+        <p:nvSpPr>
+          <p:cNvPr id="28" name="Text 26"/>
+          <p:cNvSpPr/>
+          <p:nvPr/>
+        </p:nvSpPr>
+        <p:spPr>
+          <a:xfrm>
+            <a:off x="7063740" y="3063240"/>
+            <a:ext cx="1828800" cy="274320"/>
+          </a:xfrm>
+          <a:prstGeom prst="rect">
+            <a:avLst/>
+          </a:prstGeom>
+          <a:noFill/>
+          <a:ln/>
+        </p:spPr>
+        <p:txBody>
+          <a:bodyPr wrap="square" lIns="0" tIns="0" rIns="0" bIns="0" rtlCol="0" anchor="ctr"/>
+          <a:lstStyle/>
+          <a:p>
+            <a:pPr algn="ctr" indent="0" marL="0">
+              <a:buNone/>
+            </a:pPr>
+            <a:r>
+              <a:rPr lang="en-US" sz="1100" dirty="0">
+                <a:solidFill>
+                  <a:srgbClr val="475569"/>
                 </a:solidFill>
                 <a:latin typeface="Calibri" pitchFamily="34" charset="0"/>
                 <a:ea typeface="Calibri" pitchFamily="34" charset="-122"/>
                 <a:cs typeface="Calibri" pitchFamily="34" charset="-120"/>
               </a:rPr>
-              <a:t>说明：Token 消耗、生成成功率、部署次数、P95 延迟等运行指标依赖 Actuator/Prometheus 生产抓取；本日报以仓库与 GitHub 元数据为准。</a:t>
-            </a:r>
-            <a:endParaRPr lang="en-US" sz="1200" dirty="0"/>
-          </a:p>
-        </p:txBody>
+              <a:t>全局间隔 15 秒</a:t>
+            </a:r>
+            <a:endParaRPr lang="en-US" sz="1100" dirty="0"/>
+          </a:p>
+        </p:txBody>
+      </p:sp>
+      <p:sp>
+        <p:nvSpPr>
+          <p:cNvPr id="29" name="Shape 27"/>
+          <p:cNvSpPr/>
+          <p:nvPr/>
+        </p:nvSpPr>
+        <p:spPr>
+          <a:xfrm>
+            <a:off x="457200" y="3749040"/>
+            <a:ext cx="8229600" cy="777240"/>
+          </a:xfrm>
+          <a:prstGeom prst="rect">
+            <a:avLst/>
+          </a:prstGeom>
+          <a:solidFill>
+            <a:srgbClr val="E6F7F4"/>
+          </a:solidFill>
+          <a:ln/>
+        </p:spPr>
       </p:sp>
       <p:sp>
         <p:nvSpPr>
@@ -8401,34 +8401,73 @@
         </p:nvSpPr>
         <p:spPr>
           <a:xfrm>
-            <a:off x="457200" y="4800600"/>
-            <a:ext cx="8229600" cy="228600"/>
-          </a:xfrm>
-          <a:prstGeom prst="rect">
-            <a:avLst/>
-          </a:prstGeom>
-          <a:noFill/>
-          <a:ln/>
-        </p:spPr>
-        <p:txBody>
-          <a:bodyPr wrap="square" lIns="0" tIns="0" rIns="0" bIns="0" rtlCol="0" anchor="ctr"/>
-          <a:lstStyle/>
-          <a:p>
-            <a:pPr indent="0" marL="0">
-              <a:buNone/>
-            </a:pPr>
-            <a:r>
-              <a:rPr lang="en-US" sz="1000" dirty="0">
-                <a:solidFill>
-                  <a:srgbClr val="64748B"/>
+            <a:off x="640080" y="3840480"/>
+            <a:ext cx="7863840" cy="594360"/>
+          </a:xfrm>
+          <a:prstGeom prst="rect">
+            <a:avLst/>
+          </a:prstGeom>
+          <a:noFill/>
+          <a:ln/>
+        </p:spPr>
+        <p:txBody>
+          <a:bodyPr wrap="square" lIns="0" tIns="0" rIns="0" bIns="0" rtlCol="0" anchor="ctr"/>
+          <a:lstStyle/>
+          <a:p>
+            <a:pPr indent="0" marL="0">
+              <a:buNone/>
+            </a:pPr>
+            <a:r>
+              <a:rPr lang="en-US" sz="1200" dirty="0">
+                <a:solidFill>
+                  <a:srgbClr val="334155"/>
                 </a:solidFill>
                 <a:latin typeface="Calibri" pitchFamily="34" charset="0"/>
                 <a:ea typeface="Calibri" pitchFamily="34" charset="-122"/>
                 <a:cs typeface="Calibri" pitchFamily="34" charset="-120"/>
               </a:rPr>
+              <a:t>说明：Token 消耗、生成成功率、部署次数、P95 延迟等依赖 Actuator/Prometheus 生产抓取；本日报以仓库与 GitHub 元数据为准。</a:t>
+            </a:r>
+            <a:endParaRPr lang="en-US" sz="1200" dirty="0"/>
+          </a:p>
+        </p:txBody>
+      </p:sp>
+      <p:sp>
+        <p:nvSpPr>
+          <p:cNvPr id="31" name="Text 29"/>
+          <p:cNvSpPr/>
+          <p:nvPr/>
+        </p:nvSpPr>
+        <p:spPr>
+          <a:xfrm>
+            <a:off x="457200" y="4828032"/>
+            <a:ext cx="8229600" cy="228600"/>
+          </a:xfrm>
+          <a:prstGeom prst="rect">
+            <a:avLst/>
+          </a:prstGeom>
+          <a:noFill/>
+          <a:ln/>
+        </p:spPr>
+        <p:txBody>
+          <a:bodyPr wrap="square" lIns="0" tIns="0" rIns="0" bIns="0" rtlCol="0" anchor="ctr"/>
+          <a:lstStyle/>
+          <a:p>
+            <a:pPr indent="0" marL="0">
+              <a:buNone/>
+            </a:pPr>
+            <a:r>
+              <a:rPr lang="en-US" sz="1100" dirty="0">
+                <a:solidFill>
+                  <a:srgbClr val="475569"/>
+                </a:solidFill>
+                <a:latin typeface="Calibri" pitchFamily="34" charset="0"/>
+                <a:ea typeface="Calibri" pitchFamily="34" charset="-122"/>
+                <a:cs typeface="Calibri" pitchFamily="34" charset="-120"/>
+              </a:rPr>
               <a:t>yu-ai-code-mother  ·  每日项目状态  ·  2026-08-05</a:t>
             </a:r>
-            <a:endParaRPr lang="en-US" sz="1000" dirty="0"/>
+            <a:endParaRPr lang="en-US" sz="1100" dirty="0"/>
           </a:p>
         </p:txBody>
       </p:sp>
@@ -8532,7 +8571,7 @@
         <p:spPr>
           <a:xfrm>
             <a:off x="457200" y="1005840"/>
-            <a:ext cx="8229600" cy="777240"/>
+            <a:ext cx="8229600" cy="749808"/>
           </a:xfrm>
           <a:prstGeom prst="rect">
             <a:avLst/>
@@ -8558,12 +8597,12 @@
         </p:nvSpPr>
         <p:spPr>
           <a:xfrm>
-            <a:off x="640080" y="1207008"/>
-            <a:ext cx="502920" cy="365760"/>
+            <a:off x="685800" y="1188720"/>
+            <a:ext cx="502920" cy="384048"/>
           </a:xfrm>
           <a:prstGeom prst="roundRect">
             <a:avLst>
-              <a:gd name="adj" fmla="val 15000"/>
+              <a:gd name="adj" fmla="val 14286"/>
             </a:avLst>
           </a:prstGeom>
           <a:solidFill>
@@ -8580,8 +8619,8 @@
         </p:nvSpPr>
         <p:spPr>
           <a:xfrm>
-            <a:off x="640080" y="1207008"/>
-            <a:ext cx="502920" cy="365760"/>
+            <a:off x="685800" y="1188720"/>
+            <a:ext cx="502920" cy="384048"/>
           </a:xfrm>
           <a:prstGeom prst="rect">
             <a:avLst/>
@@ -8619,8 +8658,8 @@
         </p:nvSpPr>
         <p:spPr>
           <a:xfrm>
-            <a:off x="1325880" y="1097280"/>
-            <a:ext cx="7132320" cy="274320"/>
+            <a:off x="1371600" y="1078992"/>
+            <a:ext cx="7040880" cy="274320"/>
           </a:xfrm>
           <a:prstGeom prst="rect">
             <a:avLst/>
@@ -8658,8 +8697,8 @@
         </p:nvSpPr>
         <p:spPr>
           <a:xfrm>
-            <a:off x="1325880" y="1389888"/>
-            <a:ext cx="7132320" cy="320040"/>
+            <a:off x="1371600" y="1371600"/>
+            <a:ext cx="7040880" cy="320040"/>
           </a:xfrm>
           <a:prstGeom prst="rect">
             <a:avLst/>
@@ -8683,7 +8722,7 @@
                 <a:ea typeface="Calibri" pitchFamily="34" charset="-122"/>
                 <a:cs typeface="Calibri" pitchFamily="34" charset="-120"/>
               </a:rPr>
-              <a:t>Issue #5 影响 Vue 工程生成链路；LangChain4j 未透传推理字段，工具二次调用失败。社区建议换模型或打补丁。</a:t>
+              <a:t>Issue #5：LangChain4j 未透传推理字段，Vue 工程工具二次调用失败；建议换模型或打补丁。</a:t>
             </a:r>
             <a:endParaRPr lang="en-US" sz="1200" dirty="0"/>
           </a:p>
@@ -8698,7 +8737,7 @@
         <p:spPr>
           <a:xfrm>
             <a:off x="457200" y="1874520"/>
-            <a:ext cx="8229600" cy="777240"/>
+            <a:ext cx="8229600" cy="749808"/>
           </a:xfrm>
           <a:prstGeom prst="rect">
             <a:avLst/>
@@ -8724,12 +8763,12 @@
         </p:nvSpPr>
         <p:spPr>
           <a:xfrm>
-            <a:off x="640080" y="2075688"/>
-            <a:ext cx="502920" cy="365760"/>
+            <a:off x="685800" y="2057400"/>
+            <a:ext cx="502920" cy="384048"/>
           </a:xfrm>
           <a:prstGeom prst="roundRect">
             <a:avLst>
-              <a:gd name="adj" fmla="val 15000"/>
+              <a:gd name="adj" fmla="val 14286"/>
             </a:avLst>
           </a:prstGeom>
           <a:solidFill>
@@ -8746,8 +8785,8 @@
         </p:nvSpPr>
         <p:spPr>
           <a:xfrm>
-            <a:off x="640080" y="2075688"/>
-            <a:ext cx="502920" cy="365760"/>
+            <a:off x="685800" y="2057400"/>
+            <a:ext cx="502920" cy="384048"/>
           </a:xfrm>
           <a:prstGeom prst="rect">
             <a:avLst/>
@@ -8785,8 +8824,8 @@
         </p:nvSpPr>
         <p:spPr>
           <a:xfrm>
-            <a:off x="1325880" y="1965960"/>
-            <a:ext cx="7132320" cy="274320"/>
+            <a:off x="1371600" y="1947672"/>
+            <a:ext cx="7040880" cy="274320"/>
           </a:xfrm>
           <a:prstGeom prst="rect">
             <a:avLst/>
@@ -8824,8 +8863,8 @@
         </p:nvSpPr>
         <p:spPr>
           <a:xfrm>
-            <a:off x="1325880" y="2258568"/>
-            <a:ext cx="7132320" cy="320040"/>
+            <a:off x="1371600" y="2240280"/>
+            <a:ext cx="7040880" cy="320040"/>
           </a:xfrm>
           <a:prstGeom prst="rect">
             <a:avLst/>
@@ -8849,7 +8888,7 @@
                 <a:ea typeface="Calibri" pitchFamily="34" charset="-122"/>
                 <a:cs typeface="Calibri" pitchFamily="34" charset="-120"/>
               </a:rPr>
-              <a:t>PR #66（You.com）自 2026-07-26 开放，配套 Issue #65 仍 OPEN，存在需求悬空与重复劳动风险。</a:t>
+              <a:t>PR #66（You.com）自 07-26 开放，配套 Issue #65 仍 OPEN，存在需求悬空与重复劳动风险。</a:t>
             </a:r>
             <a:endParaRPr lang="en-US" sz="1200" dirty="0"/>
           </a:p>
@@ -8864,7 +8903,7 @@
         <p:spPr>
           <a:xfrm>
             <a:off x="457200" y="2743200"/>
-            <a:ext cx="8229600" cy="777240"/>
+            <a:ext cx="8229600" cy="749808"/>
           </a:xfrm>
           <a:prstGeom prst="rect">
             <a:avLst/>
@@ -8890,12 +8929,12 @@
         </p:nvSpPr>
         <p:spPr>
           <a:xfrm>
-            <a:off x="640080" y="2944368"/>
-            <a:ext cx="502920" cy="365760"/>
+            <a:off x="685800" y="2926080"/>
+            <a:ext cx="502920" cy="384048"/>
           </a:xfrm>
           <a:prstGeom prst="roundRect">
             <a:avLst>
-              <a:gd name="adj" fmla="val 15000"/>
+              <a:gd name="adj" fmla="val 14286"/>
             </a:avLst>
           </a:prstGeom>
           <a:solidFill>
@@ -8912,8 +8951,8 @@
         </p:nvSpPr>
         <p:spPr>
           <a:xfrm>
-            <a:off x="640080" y="2944368"/>
-            <a:ext cx="502920" cy="365760"/>
+            <a:off x="685800" y="2926080"/>
+            <a:ext cx="502920" cy="384048"/>
           </a:xfrm>
           <a:prstGeom prst="rect">
             <a:avLst/>
@@ -8951,8 +8990,8 @@
         </p:nvSpPr>
         <p:spPr>
           <a:xfrm>
-            <a:off x="1325880" y="2834640"/>
-            <a:ext cx="7132320" cy="274320"/>
+            <a:off x="1371600" y="2816352"/>
+            <a:ext cx="7040880" cy="274320"/>
           </a:xfrm>
           <a:prstGeom prst="rect">
             <a:avLst/>
@@ -8990,8 +9029,8 @@
         </p:nvSpPr>
         <p:spPr>
           <a:xfrm>
-            <a:off x="1325880" y="3127248"/>
-            <a:ext cx="7132320" cy="320040"/>
+            <a:off x="1371600" y="3108960"/>
+            <a:ext cx="7040880" cy="320040"/>
           </a:xfrm>
           <a:prstGeom prst="rect">
             <a:avLst/>
@@ -9015,7 +9054,7 @@
                 <a:ea typeface="Calibri" pitchFamily="34" charset="-122"/>
                 <a:cs typeface="Calibri" pitchFamily="34" charset="-120"/>
               </a:rPr>
-              <a:t>仓库无 Maven/前端构建与测试的 GitHub Actions；近期仅有 Copilot 访问检查成功记录。</a:t>
+              <a:t>无 Maven/前端构建与测试的 GitHub Actions；近期仅有 Copilot 仓库访问检查成功记录。</a:t>
             </a:r>
             <a:endParaRPr lang="en-US" sz="1200" dirty="0"/>
           </a:p>
@@ -9030,7 +9069,7 @@
         <p:spPr>
           <a:xfrm>
             <a:off x="457200" y="3611880"/>
-            <a:ext cx="8229600" cy="777240"/>
+            <a:ext cx="8229600" cy="749808"/>
           </a:xfrm>
           <a:prstGeom prst="rect">
             <a:avLst/>
@@ -9056,12 +9095,12 @@
         </p:nvSpPr>
         <p:spPr>
           <a:xfrm>
-            <a:off x="640080" y="3813048"/>
-            <a:ext cx="502920" cy="365760"/>
+            <a:off x="685800" y="3794760"/>
+            <a:ext cx="502920" cy="384048"/>
           </a:xfrm>
           <a:prstGeom prst="roundRect">
             <a:avLst>
-              <a:gd name="adj" fmla="val 15000"/>
+              <a:gd name="adj" fmla="val 14286"/>
             </a:avLst>
           </a:prstGeom>
           <a:solidFill>
@@ -9078,8 +9117,8 @@
         </p:nvSpPr>
         <p:spPr>
           <a:xfrm>
-            <a:off x="640080" y="3813048"/>
-            <a:ext cx="502920" cy="365760"/>
+            <a:off x="685800" y="3794760"/>
+            <a:ext cx="502920" cy="384048"/>
           </a:xfrm>
           <a:prstGeom prst="rect">
             <a:avLst/>
@@ -9117,8 +9156,8 @@
         </p:nvSpPr>
         <p:spPr>
           <a:xfrm>
-            <a:off x="1325880" y="3703320"/>
-            <a:ext cx="7132320" cy="274320"/>
+            <a:off x="1371600" y="3685032"/>
+            <a:ext cx="7040880" cy="274320"/>
           </a:xfrm>
           <a:prstGeom prst="rect">
             <a:avLst/>
@@ -9156,8 +9195,8 @@
         </p:nvSpPr>
         <p:spPr>
           <a:xfrm>
-            <a:off x="1325880" y="3995928"/>
-            <a:ext cx="7132320" cy="320040"/>
+            <a:off x="1371600" y="3977640"/>
+            <a:ext cx="7040880" cy="320040"/>
           </a:xfrm>
           <a:prstGeom prst="rect">
             <a:avLst/>
@@ -9181,7 +9220,7 @@
                 <a:ea typeface="Calibri" pitchFamily="34" charset="-122"/>
                 <a:cs typeface="Calibri" pitchFamily="34" charset="-120"/>
               </a:rPr>
-              <a:t>多日「每日项目状态」Draft PR（含昨日 #75）未合并，文档分支噪音增大，建议定期合入或清理策略。</a:t>
+              <a:t>多日状态汇报 Draft PR（含昨日 #75）未合并，分支噪音增大，建议定期合入或归档。</a:t>
             </a:r>
             <a:endParaRPr lang="en-US" sz="1200" dirty="0"/>
           </a:p>
@@ -9195,7 +9234,7 @@
         </p:nvSpPr>
         <p:spPr>
           <a:xfrm>
-            <a:off x="457200" y="4800600"/>
+            <a:off x="457200" y="4828032"/>
             <a:ext cx="8229600" cy="228600"/>
           </a:xfrm>
           <a:prstGeom prst="rect">
@@ -9212,9 +9251,9 @@
               <a:buNone/>
             </a:pPr>
             <a:r>
-              <a:rPr lang="en-US" sz="1000" dirty="0">
-                <a:solidFill>
-                  <a:srgbClr val="64748B"/>
+              <a:rPr lang="en-US" sz="1100" dirty="0">
+                <a:solidFill>
+                  <a:srgbClr val="475569"/>
                 </a:solidFill>
                 <a:latin typeface="Calibri" pitchFamily="34" charset="0"/>
                 <a:ea typeface="Calibri" pitchFamily="34" charset="-122"/>
@@ -9222,7 +9261,7 @@
               </a:rPr>
               <a:t>yu-ai-code-mother  ·  每日项目状态  ·  2026-08-05</a:t>
             </a:r>
-            <a:endParaRPr lang="en-US" sz="1000" dirty="0"/>
+            <a:endParaRPr lang="en-US" sz="1100" dirty="0"/>
           </a:p>
         </p:txBody>
       </p:sp>
@@ -9326,7 +9365,7 @@
         <p:spPr>
           <a:xfrm>
             <a:off x="457200" y="1005840"/>
-            <a:ext cx="8229600" cy="594360"/>
+            <a:ext cx="8229600" cy="603504"/>
           </a:xfrm>
           <a:prstGeom prst="rect">
             <a:avLst/>
@@ -9352,7 +9391,7 @@
         </p:nvSpPr>
         <p:spPr>
           <a:xfrm>
-            <a:off x="640080" y="1097280"/>
+            <a:off x="685800" y="1097280"/>
             <a:ext cx="411480" cy="411480"/>
           </a:xfrm>
           <a:prstGeom prst="ellipse">
@@ -9372,7 +9411,7 @@
         </p:nvSpPr>
         <p:spPr>
           <a:xfrm>
-            <a:off x="640080" y="1097280"/>
+            <a:off x="685800" y="1097280"/>
             <a:ext cx="411480" cy="411480"/>
           </a:xfrm>
           <a:prstGeom prst="rect">
@@ -9411,8 +9450,8 @@
         </p:nvSpPr>
         <p:spPr>
           <a:xfrm>
-            <a:off x="1280160" y="1078992"/>
-            <a:ext cx="3200400" cy="457200"/>
+            <a:off x="1325880" y="1078992"/>
+            <a:ext cx="2560320" cy="457200"/>
           </a:xfrm>
           <a:prstGeom prst="rect">
             <a:avLst/>
@@ -9450,8 +9489,8 @@
         </p:nvSpPr>
         <p:spPr>
           <a:xfrm>
-            <a:off x="4572000" y="1078992"/>
-            <a:ext cx="3931920" cy="457200"/>
+            <a:off x="4023360" y="1078992"/>
+            <a:ext cx="4480560" cy="457200"/>
           </a:xfrm>
           <a:prstGeom prst="rect">
             <a:avLst/>
@@ -9475,7 +9514,7 @@
                 <a:ea typeface="Calibri" pitchFamily="34" charset="-122"/>
                 <a:cs typeface="Calibri" pitchFamily="34" charset="-120"/>
               </a:rPr>
-              <a:t>评估补丁或换模型；验证 Vue 工程模式工具调用</a:t>
+              <a:t>评估补丁或换模型，验证 Vue 工程模式工具调用</a:t>
             </a:r>
             <a:endParaRPr lang="en-US" sz="1300" dirty="0"/>
           </a:p>
@@ -9489,8 +9528,8 @@
         </p:nvSpPr>
         <p:spPr>
           <a:xfrm>
-            <a:off x="457200" y="1691640"/>
-            <a:ext cx="8229600" cy="594360"/>
+            <a:off x="457200" y="1700784"/>
+            <a:ext cx="8229600" cy="603504"/>
           </a:xfrm>
           <a:prstGeom prst="rect">
             <a:avLst/>
@@ -9516,7 +9555,7 @@
         </p:nvSpPr>
         <p:spPr>
           <a:xfrm>
-            <a:off x="640080" y="1783080"/>
+            <a:off x="685800" y="1792224"/>
             <a:ext cx="411480" cy="411480"/>
           </a:xfrm>
           <a:prstGeom prst="ellipse">
@@ -9536,7 +9575,7 @@
         </p:nvSpPr>
         <p:spPr>
           <a:xfrm>
-            <a:off x="640080" y="1783080"/>
+            <a:off x="685800" y="1792224"/>
             <a:ext cx="411480" cy="411480"/>
           </a:xfrm>
           <a:prstGeom prst="rect">
@@ -9575,8 +9614,8 @@
         </p:nvSpPr>
         <p:spPr>
           <a:xfrm>
-            <a:off x="1280160" y="1764792"/>
-            <a:ext cx="3200400" cy="457200"/>
+            <a:off x="1325880" y="1773936"/>
+            <a:ext cx="2560320" cy="457200"/>
           </a:xfrm>
           <a:prstGeom prst="rect">
             <a:avLst/>
@@ -9614,8 +9653,8 @@
         </p:nvSpPr>
         <p:spPr>
           <a:xfrm>
-            <a:off x="4572000" y="1764792"/>
-            <a:ext cx="3931920" cy="457200"/>
+            <a:off x="4023360" y="1773936"/>
+            <a:ext cx="4480560" cy="457200"/>
           </a:xfrm>
           <a:prstGeom prst="rect">
             <a:avLst/>
@@ -9639,7 +9678,7 @@
                 <a:ea typeface="Calibri" pitchFamily="34" charset="-122"/>
                 <a:cs typeface="Calibri" pitchFamily="34" charset="-120"/>
               </a:rPr>
-              <a:t>核对 API Key、单测与微服务 AI 模块集成后合并</a:t>
+              <a:t>核对 API Key、单测与微服务 AI 模块后合并</a:t>
             </a:r>
             <a:endParaRPr lang="en-US" sz="1300" dirty="0"/>
           </a:p>
@@ -9653,8 +9692,8 @@
         </p:nvSpPr>
         <p:spPr>
           <a:xfrm>
-            <a:off x="457200" y="2377440"/>
-            <a:ext cx="8229600" cy="594360"/>
+            <a:off x="457200" y="2395728"/>
+            <a:ext cx="8229600" cy="603504"/>
           </a:xfrm>
           <a:prstGeom prst="rect">
             <a:avLst/>
@@ -9680,7 +9719,7 @@
         </p:nvSpPr>
         <p:spPr>
           <a:xfrm>
-            <a:off x="640080" y="2468880"/>
+            <a:off x="685800" y="2487168"/>
             <a:ext cx="411480" cy="411480"/>
           </a:xfrm>
           <a:prstGeom prst="ellipse">
@@ -9700,7 +9739,7 @@
         </p:nvSpPr>
         <p:spPr>
           <a:xfrm>
-            <a:off x="640080" y="2468880"/>
+            <a:off x="685800" y="2487168"/>
             <a:ext cx="411480" cy="411480"/>
           </a:xfrm>
           <a:prstGeom prst="rect">
@@ -9739,8 +9778,8 @@
         </p:nvSpPr>
         <p:spPr>
           <a:xfrm>
-            <a:off x="1280160" y="2450592"/>
-            <a:ext cx="3200400" cy="457200"/>
+            <a:off x="1325880" y="2468880"/>
+            <a:ext cx="2560320" cy="457200"/>
           </a:xfrm>
           <a:prstGeom prst="rect">
             <a:avLst/>
@@ -9764,7 +9803,7 @@
                 <a:ea typeface="Georgia" pitchFamily="34" charset="-122"/>
                 <a:cs typeface="Georgia" pitchFamily="34" charset="-120"/>
               </a:rPr>
-              <a:t>补最小 CI</a:t>
+              <a:t>补齐最小 CI</a:t>
             </a:r>
             <a:endParaRPr lang="en-US" sz="1600" dirty="0"/>
           </a:p>
@@ -9778,8 +9817,8 @@
         </p:nvSpPr>
         <p:spPr>
           <a:xfrm>
-            <a:off x="4572000" y="2450592"/>
-            <a:ext cx="3931920" cy="457200"/>
+            <a:off x="4023360" y="2468880"/>
+            <a:ext cx="4480560" cy="457200"/>
           </a:xfrm>
           <a:prstGeom prst="rect">
             <a:avLst/>
@@ -9803,7 +9842,7 @@
                 <a:ea typeface="Calibri" pitchFamily="34" charset="-122"/>
                 <a:cs typeface="Calibri" pitchFamily="34" charset="-120"/>
               </a:rPr>
-              <a:t>为单体 / 微服务与前端增加构建与单测工作流</a:t>
+              <a:t>为单体、微服务与前端增加构建与单测工作流</a:t>
             </a:r>
             <a:endParaRPr lang="en-US" sz="1300" dirty="0"/>
           </a:p>
@@ -9817,8 +9856,8 @@
         </p:nvSpPr>
         <p:spPr>
           <a:xfrm>
-            <a:off x="457200" y="3063240"/>
-            <a:ext cx="8229600" cy="594360"/>
+            <a:off x="457200" y="3090672"/>
+            <a:ext cx="8229600" cy="603504"/>
           </a:xfrm>
           <a:prstGeom prst="rect">
             <a:avLst/>
@@ -9844,7 +9883,7 @@
         </p:nvSpPr>
         <p:spPr>
           <a:xfrm>
-            <a:off x="640080" y="3154680"/>
+            <a:off x="685800" y="3182112"/>
             <a:ext cx="411480" cy="411480"/>
           </a:xfrm>
           <a:prstGeom prst="ellipse">
@@ -9864,7 +9903,7 @@
         </p:nvSpPr>
         <p:spPr>
           <a:xfrm>
-            <a:off x="640080" y="3154680"/>
+            <a:off x="685800" y="3182112"/>
             <a:ext cx="411480" cy="411480"/>
           </a:xfrm>
           <a:prstGeom prst="rect">
@@ -9903,8 +9942,8 @@
         </p:nvSpPr>
         <p:spPr>
           <a:xfrm>
-            <a:off x="1280160" y="3136392"/>
-            <a:ext cx="3200400" cy="457200"/>
+            <a:off x="1325880" y="3163824"/>
+            <a:ext cx="2560320" cy="457200"/>
           </a:xfrm>
           <a:prstGeom prst="rect">
             <a:avLst/>
@@ -9942,8 +9981,8 @@
         </p:nvSpPr>
         <p:spPr>
           <a:xfrm>
-            <a:off x="4572000" y="3136392"/>
-            <a:ext cx="3931920" cy="457200"/>
+            <a:off x="4023360" y="3163824"/>
+            <a:ext cx="4480560" cy="457200"/>
           </a:xfrm>
           <a:prstGeom prst="rect">
             <a:avLst/>
@@ -9981,8 +10020,8 @@
         </p:nvSpPr>
         <p:spPr>
           <a:xfrm>
-            <a:off x="457200" y="3749040"/>
-            <a:ext cx="8229600" cy="594360"/>
+            <a:off x="457200" y="3785616"/>
+            <a:ext cx="8229600" cy="603504"/>
           </a:xfrm>
           <a:prstGeom prst="rect">
             <a:avLst/>
@@ -10008,7 +10047,7 @@
         </p:nvSpPr>
         <p:spPr>
           <a:xfrm>
-            <a:off x="640080" y="3840480"/>
+            <a:off x="685800" y="3877056"/>
             <a:ext cx="411480" cy="411480"/>
           </a:xfrm>
           <a:prstGeom prst="ellipse">
@@ -10028,7 +10067,7 @@
         </p:nvSpPr>
         <p:spPr>
           <a:xfrm>
-            <a:off x="640080" y="3840480"/>
+            <a:off x="685800" y="3877056"/>
             <a:ext cx="411480" cy="411480"/>
           </a:xfrm>
           <a:prstGeom prst="rect">
@@ -10067,8 +10106,8 @@
         </p:nvSpPr>
         <p:spPr>
           <a:xfrm>
-            <a:off x="1280160" y="3822192"/>
-            <a:ext cx="3200400" cy="457200"/>
+            <a:off x="1325880" y="3858768"/>
+            <a:ext cx="2560320" cy="457200"/>
           </a:xfrm>
           <a:prstGeom prst="rect">
             <a:avLst/>
@@ -10106,8 +10145,8 @@
         </p:nvSpPr>
         <p:spPr>
           <a:xfrm>
-            <a:off x="4572000" y="3822192"/>
-            <a:ext cx="3931920" cy="457200"/>
+            <a:off x="4023360" y="3858768"/>
+            <a:ext cx="4480560" cy="457200"/>
           </a:xfrm>
           <a:prstGeom prst="rect">
             <a:avLst/>
@@ -10131,7 +10170,7 @@
                 <a:ea typeface="Calibri" pitchFamily="34" charset="-122"/>
                 <a:cs typeface="Calibri" pitchFamily="34" charset="-120"/>
               </a:rPr>
-              <a:t>制定日报合入节奏或归档规则，降低 PR 噪音</a:t>
+              <a:t>制定日报合入节奏或归档规则，降低噪音</a:t>
             </a:r>
             <a:endParaRPr lang="en-US" sz="1300" dirty="0"/>
           </a:p>
@@ -10145,7 +10184,7 @@
         </p:nvSpPr>
         <p:spPr>
           <a:xfrm>
-            <a:off x="457200" y="4800600"/>
+            <a:off x="457200" y="4828032"/>
             <a:ext cx="8229600" cy="228600"/>
           </a:xfrm>
           <a:prstGeom prst="rect">
@@ -10162,9 +10201,9 @@
               <a:buNone/>
             </a:pPr>
             <a:r>
-              <a:rPr lang="en-US" sz="1000" dirty="0">
-                <a:solidFill>
-                  <a:srgbClr val="64748B"/>
+              <a:rPr lang="en-US" sz="1100" dirty="0">
+                <a:solidFill>
+                  <a:srgbClr val="475569"/>
                 </a:solidFill>
                 <a:latin typeface="Calibri" pitchFamily="34" charset="0"/>
                 <a:ea typeface="Calibri" pitchFamily="34" charset="-122"/>
@@ -10172,7 +10211,7 @@
               </a:rPr>
               <a:t>yu-ai-code-mother  ·  每日项目状态  ·  2026-08-05</a:t>
             </a:r>
-            <a:endParaRPr lang="en-US" sz="1000" dirty="0"/>
+            <a:endParaRPr lang="en-US" sz="1100" dirty="0"/>
           </a:p>
         </p:txBody>
       </p:sp>
@@ -10276,7 +10315,7 @@
         <p:spPr>
           <a:xfrm>
             <a:off x="457200" y="1051560"/>
-            <a:ext cx="4023360" cy="3383280"/>
+            <a:ext cx="4069080" cy="3383280"/>
           </a:xfrm>
           <a:prstGeom prst="rect">
             <a:avLst/>
@@ -10303,7 +10342,7 @@
         <p:spPr>
           <a:xfrm>
             <a:off x="457200" y="1051560"/>
-            <a:ext cx="4023360" cy="502920"/>
+            <a:ext cx="4069080" cy="502920"/>
           </a:xfrm>
           <a:prstGeom prst="rect">
             <a:avLst/>
@@ -10386,23 +10425,23 @@
         <p:spPr>
           <a:xfrm>
             <a:off x="731520" y="1783080"/>
-            <a:ext cx="3566160" cy="502920"/>
-          </a:xfrm>
-          <a:prstGeom prst="rect">
-            <a:avLst/>
-          </a:prstGeom>
-          <a:noFill/>
-          <a:ln/>
-        </p:spPr>
-        <p:txBody>
-          <a:bodyPr wrap="square" lIns="0" tIns="0" rIns="0" bIns="0" rtlCol="0" anchor="ctr"/>
-          <a:lstStyle/>
-          <a:p>
-            <a:pPr indent="0" marL="0">
-              <a:buNone/>
-            </a:pPr>
-            <a:r>
-              <a:rPr lang="en-US" sz="1300" dirty="0">
+            <a:ext cx="3566160" cy="457200"/>
+          </a:xfrm>
+          <a:prstGeom prst="rect">
+            <a:avLst/>
+          </a:prstGeom>
+          <a:noFill/>
+          <a:ln/>
+        </p:spPr>
+        <p:txBody>
+          <a:bodyPr wrap="square" lIns="0" tIns="0" rIns="0" bIns="0" rtlCol="0" anchor="ctr"/>
+          <a:lstStyle/>
+          <a:p>
+            <a:pPr indent="0" marL="0">
+              <a:buNone/>
+            </a:pPr>
+            <a:r>
+              <a:rPr lang="en-US" sz="1400" dirty="0">
                 <a:solidFill>
                   <a:srgbClr val="334155"/>
                 </a:solidFill>
@@ -10410,9 +10449,9 @@
                 <a:ea typeface="Calibri" pitchFamily="34" charset="-122"/>
                 <a:cs typeface="Calibri" pitchFamily="34" charset="-120"/>
               </a:rPr>
-              <a:t>▸  Issue #5：缺 reasoning_content，Vue 生成失败</a:t>
-            </a:r>
-            <a:endParaRPr lang="en-US" sz="1300" dirty="0"/>
+              <a:t>▸  Issue #5：reasoning_content 缺失</a:t>
+            </a:r>
+            <a:endParaRPr lang="en-US" sz="1400" dirty="0"/>
           </a:p>
         </p:txBody>
       </p:sp>
@@ -10425,23 +10464,23 @@
         <p:spPr>
           <a:xfrm>
             <a:off x="731520" y="2377440"/>
-            <a:ext cx="3566160" cy="502920"/>
-          </a:xfrm>
-          <a:prstGeom prst="rect">
-            <a:avLst/>
-          </a:prstGeom>
-          <a:noFill/>
-          <a:ln/>
-        </p:spPr>
-        <p:txBody>
-          <a:bodyPr wrap="square" lIns="0" tIns="0" rIns="0" bIns="0" rtlCol="0" anchor="ctr"/>
-          <a:lstStyle/>
-          <a:p>
-            <a:pPr indent="0" marL="0">
-              <a:buNone/>
-            </a:pPr>
-            <a:r>
-              <a:rPr lang="en-US" sz="1300" dirty="0">
+            <a:ext cx="3566160" cy="457200"/>
+          </a:xfrm>
+          <a:prstGeom prst="rect">
+            <a:avLst/>
+          </a:prstGeom>
+          <a:noFill/>
+          <a:ln/>
+        </p:spPr>
+        <p:txBody>
+          <a:bodyPr wrap="square" lIns="0" tIns="0" rIns="0" bIns="0" rtlCol="0" anchor="ctr"/>
+          <a:lstStyle/>
+          <a:p>
+            <a:pPr indent="0" marL="0">
+              <a:buNone/>
+            </a:pPr>
+            <a:r>
+              <a:rPr lang="en-US" sz="1400" dirty="0">
                 <a:solidFill>
                   <a:srgbClr val="334155"/>
                 </a:solidFill>
@@ -10449,9 +10488,9 @@
                 <a:ea typeface="Calibri" pitchFamily="34" charset="-122"/>
                 <a:cs typeface="Calibri" pitchFamily="34" charset="-120"/>
               </a:rPr>
-              <a:t>▸  模型接口变更，需兼容层或升级策略</a:t>
-            </a:r>
-            <a:endParaRPr lang="en-US" sz="1300" dirty="0"/>
+              <a:t>▸  Vue 工程生成链路仍失败</a:t>
+            </a:r>
+            <a:endParaRPr lang="en-US" sz="1400" dirty="0"/>
           </a:p>
         </p:txBody>
       </p:sp>
@@ -10464,23 +10503,23 @@
         <p:spPr>
           <a:xfrm>
             <a:off x="731520" y="2971800"/>
-            <a:ext cx="3566160" cy="502920"/>
-          </a:xfrm>
-          <a:prstGeom prst="rect">
-            <a:avLst/>
-          </a:prstGeom>
-          <a:noFill/>
-          <a:ln/>
-        </p:spPr>
-        <p:txBody>
-          <a:bodyPr wrap="square" lIns="0" tIns="0" rIns="0" bIns="0" rtlCol="0" anchor="ctr"/>
-          <a:lstStyle/>
-          <a:p>
-            <a:pPr indent="0" marL="0">
-              <a:buNone/>
-            </a:pPr>
-            <a:r>
-              <a:rPr lang="en-US" sz="1300" dirty="0">
+            <a:ext cx="3566160" cy="457200"/>
+          </a:xfrm>
+          <a:prstGeom prst="rect">
+            <a:avLst/>
+          </a:prstGeom>
+          <a:noFill/>
+          <a:ln/>
+        </p:spPr>
+        <p:txBody>
+          <a:bodyPr wrap="square" lIns="0" tIns="0" rIns="0" bIns="0" rtlCol="0" anchor="ctr"/>
+          <a:lstStyle/>
+          <a:p>
+            <a:pPr indent="0" marL="0">
+              <a:buNone/>
+            </a:pPr>
+            <a:r>
+              <a:rPr lang="en-US" sz="1400" dirty="0">
                 <a:solidFill>
                   <a:srgbClr val="334155"/>
                 </a:solidFill>
@@ -10488,9 +10527,9 @@
                 <a:ea typeface="Calibri" pitchFamily="34" charset="-122"/>
                 <a:cs typeface="Calibri" pitchFamily="34" charset="-120"/>
               </a:rPr>
-              <a:t>▸  社区仍反馈未解决，优先于新特性</a:t>
-            </a:r>
-            <a:endParaRPr lang="en-US" sz="1300" dirty="0"/>
+              <a:t>▸  模型接口变更需兼容层策略</a:t>
+            </a:r>
+            <a:endParaRPr lang="en-US" sz="1400" dirty="0"/>
           </a:p>
         </p:txBody>
       </p:sp>
@@ -10503,23 +10542,23 @@
         <p:spPr>
           <a:xfrm>
             <a:off x="731520" y="3566160"/>
-            <a:ext cx="3566160" cy="502920"/>
-          </a:xfrm>
-          <a:prstGeom prst="rect">
-            <a:avLst/>
-          </a:prstGeom>
-          <a:noFill/>
-          <a:ln/>
-        </p:spPr>
-        <p:txBody>
-          <a:bodyPr wrap="square" lIns="0" tIns="0" rIns="0" bIns="0" rtlCol="0" anchor="ctr"/>
-          <a:lstStyle/>
-          <a:p>
-            <a:pPr indent="0" marL="0">
-              <a:buNone/>
-            </a:pPr>
-            <a:r>
-              <a:rPr lang="en-US" sz="1300" dirty="0">
+            <a:ext cx="3566160" cy="457200"/>
+          </a:xfrm>
+          <a:prstGeom prst="rect">
+            <a:avLst/>
+          </a:prstGeom>
+          <a:noFill/>
+          <a:ln/>
+        </p:spPr>
+        <p:txBody>
+          <a:bodyPr wrap="square" lIns="0" tIns="0" rIns="0" bIns="0" rtlCol="0" anchor="ctr"/>
+          <a:lstStyle/>
+          <a:p>
+            <a:pPr indent="0" marL="0">
+              <a:buNone/>
+            </a:pPr>
+            <a:r>
+              <a:rPr lang="en-US" sz="1400" dirty="0">
                 <a:solidFill>
                   <a:srgbClr val="334155"/>
                 </a:solidFill>
@@ -10527,9 +10566,9 @@
                 <a:ea typeface="Calibri" pitchFamily="34" charset="-122"/>
                 <a:cs typeface="Calibri" pitchFamily="34" charset="-120"/>
               </a:rPr>
-              <a:t>▸  补充工程模式多轮工具调用回归用例</a:t>
-            </a:r>
-            <a:endParaRPr lang="en-US" sz="1300" dirty="0"/>
+              <a:t>▸  需补多轮工具调用回归用例</a:t>
+            </a:r>
+            <a:endParaRPr lang="en-US" sz="1400" dirty="0"/>
           </a:p>
         </p:txBody>
       </p:sp>
@@ -10541,8 +10580,8 @@
         </p:nvSpPr>
         <p:spPr>
           <a:xfrm>
-            <a:off x="4663440" y="1051560"/>
-            <a:ext cx="4023360" cy="3383280"/>
+            <a:off x="4754880" y="1051560"/>
+            <a:ext cx="3931920" cy="3383280"/>
           </a:xfrm>
           <a:prstGeom prst="rect">
             <a:avLst/>
@@ -10568,8 +10607,8 @@
         </p:nvSpPr>
         <p:spPr>
           <a:xfrm>
-            <a:off x="4663440" y="1051560"/>
-            <a:ext cx="4023360" cy="502920"/>
+            <a:off x="4754880" y="1051560"/>
+            <a:ext cx="3931920" cy="502920"/>
           </a:xfrm>
           <a:prstGeom prst="rect">
             <a:avLst/>
@@ -10596,7 +10635,7 @@
         </p:blipFill>
         <p:spPr>
           <a:xfrm>
-            <a:off x="4846320" y="1161288"/>
+            <a:off x="4937760" y="1161288"/>
             <a:ext cx="274320" cy="274320"/>
           </a:xfrm>
           <a:prstGeom prst="rect">
@@ -10612,8 +10651,8 @@
         </p:nvSpPr>
         <p:spPr>
           <a:xfrm>
-            <a:off x="5257800" y="1051560"/>
-            <a:ext cx="3200400" cy="502920"/>
+            <a:off x="5349240" y="1051560"/>
+            <a:ext cx="3108960" cy="502920"/>
           </a:xfrm>
           <a:prstGeom prst="rect">
             <a:avLst/>
@@ -10651,24 +10690,24 @@
         </p:nvSpPr>
         <p:spPr>
           <a:xfrm>
-            <a:off x="4937760" y="1783080"/>
-            <a:ext cx="3566160" cy="502920"/>
-          </a:xfrm>
-          <a:prstGeom prst="rect">
-            <a:avLst/>
-          </a:prstGeom>
-          <a:noFill/>
-          <a:ln/>
-        </p:spPr>
-        <p:txBody>
-          <a:bodyPr wrap="square" lIns="0" tIns="0" rIns="0" bIns="0" rtlCol="0" anchor="ctr"/>
-          <a:lstStyle/>
-          <a:p>
-            <a:pPr indent="0" marL="0">
-              <a:buNone/>
-            </a:pPr>
-            <a:r>
-              <a:rPr lang="en-US" sz="1300" dirty="0">
+            <a:off x="5029200" y="1783080"/>
+            <a:ext cx="3474720" cy="457200"/>
+          </a:xfrm>
+          <a:prstGeom prst="rect">
+            <a:avLst/>
+          </a:prstGeom>
+          <a:noFill/>
+          <a:ln/>
+        </p:spPr>
+        <p:txBody>
+          <a:bodyPr wrap="square" lIns="0" tIns="0" rIns="0" bIns="0" rtlCol="0" anchor="ctr"/>
+          <a:lstStyle/>
+          <a:p>
+            <a:pPr indent="0" marL="0">
+              <a:buNone/>
+            </a:pPr>
+            <a:r>
+              <a:rPr lang="en-US" sz="1400" dirty="0">
                 <a:solidFill>
                   <a:srgbClr val="334155"/>
                 </a:solidFill>
@@ -10676,9 +10715,9 @@
                 <a:ea typeface="Calibri" pitchFamily="34" charset="-122"/>
                 <a:cs typeface="Calibri" pitchFamily="34" charset="-120"/>
               </a:rPr>
-              <a:t>▸  Issue #65 / PR #66：You.com 搜索待合入</a:t>
-            </a:r>
-            <a:endParaRPr lang="en-US" sz="1300" dirty="0"/>
+              <a:t>▸  PR #66 / Issue #65 待合入</a:t>
+            </a:r>
+            <a:endParaRPr lang="en-US" sz="1400" dirty="0"/>
           </a:p>
         </p:txBody>
       </p:sp>
@@ -10690,24 +10729,24 @@
         </p:nvSpPr>
         <p:spPr>
           <a:xfrm>
-            <a:off x="4937760" y="2377440"/>
-            <a:ext cx="3566160" cy="502920"/>
-          </a:xfrm>
-          <a:prstGeom prst="rect">
-            <a:avLst/>
-          </a:prstGeom>
-          <a:noFill/>
-          <a:ln/>
-        </p:spPr>
-        <p:txBody>
-          <a:bodyPr wrap="square" lIns="0" tIns="0" rIns="0" bIns="0" rtlCol="0" anchor="ctr"/>
-          <a:lstStyle/>
-          <a:p>
-            <a:pPr indent="0" marL="0">
-              <a:buNone/>
-            </a:pPr>
-            <a:r>
-              <a:rPr lang="en-US" sz="1300" dirty="0">
+            <a:off x="5029200" y="2377440"/>
+            <a:ext cx="3474720" cy="457200"/>
+          </a:xfrm>
+          <a:prstGeom prst="rect">
+            <a:avLst/>
+          </a:prstGeom>
+          <a:noFill/>
+          <a:ln/>
+        </p:spPr>
+        <p:txBody>
+          <a:bodyPr wrap="square" lIns="0" tIns="0" rIns="0" bIns="0" rtlCol="0" anchor="ctr"/>
+          <a:lstStyle/>
+          <a:p>
+            <a:pPr indent="0" marL="0">
+              <a:buNone/>
+            </a:pPr>
+            <a:r>
+              <a:rPr lang="en-US" sz="1400" dirty="0">
                 <a:solidFill>
                   <a:srgbClr val="334155"/>
                 </a:solidFill>
@@ -10715,9 +10754,9 @@
                 <a:ea typeface="Calibri" pitchFamily="34" charset="-122"/>
                 <a:cs typeface="Calibri" pitchFamily="34" charset="-120"/>
               </a:rPr>
-              <a:t>▸  业务向 CI/CD 流水线尚未建立</a:t>
-            </a:r>
-            <a:endParaRPr lang="en-US" sz="1300" dirty="0"/>
+              <a:t>▸  业务向 CI/CD 尚未建立</a:t>
+            </a:r>
+            <a:endParaRPr lang="en-US" sz="1400" dirty="0"/>
           </a:p>
         </p:txBody>
       </p:sp>
@@ -10729,24 +10768,24 @@
         </p:nvSpPr>
         <p:spPr>
           <a:xfrm>
-            <a:off x="4937760" y="2971800"/>
-            <a:ext cx="3566160" cy="502920"/>
-          </a:xfrm>
-          <a:prstGeom prst="rect">
-            <a:avLst/>
-          </a:prstGeom>
-          <a:noFill/>
-          <a:ln/>
-        </p:spPr>
-        <p:txBody>
-          <a:bodyPr wrap="square" lIns="0" tIns="0" rIns="0" bIns="0" rtlCol="0" anchor="ctr"/>
-          <a:lstStyle/>
-          <a:p>
-            <a:pPr indent="0" marL="0">
-              <a:buNone/>
-            </a:pPr>
-            <a:r>
-              <a:rPr lang="en-US" sz="1300" dirty="0">
+            <a:off x="5029200" y="2971800"/>
+            <a:ext cx="3474720" cy="457200"/>
+          </a:xfrm>
+          <a:prstGeom prst="rect">
+            <a:avLst/>
+          </a:prstGeom>
+          <a:noFill/>
+          <a:ln/>
+        </p:spPr>
+        <p:txBody>
+          <a:bodyPr wrap="square" lIns="0" tIns="0" rIns="0" bIns="0" rtlCol="0" anchor="ctr"/>
+          <a:lstStyle/>
+          <a:p>
+            <a:pPr indent="0" marL="0">
+              <a:buNone/>
+            </a:pPr>
+            <a:r>
+              <a:rPr lang="en-US" sz="1400" dirty="0">
                 <a:solidFill>
                   <a:srgbClr val="334155"/>
                 </a:solidFill>
@@ -10754,9 +10793,9 @@
                 <a:ea typeface="Calibri" pitchFamily="34" charset="-122"/>
                 <a:cs typeface="Calibri" pitchFamily="34" charset="-120"/>
               </a:rPr>
-              <a:t>▸  运行时 KPI 尚未进入日报自动化</a:t>
-            </a:r>
-            <a:endParaRPr lang="en-US" sz="1300" dirty="0"/>
+              <a:t>▸  运行时 KPI 未入日报</a:t>
+            </a:r>
+            <a:endParaRPr lang="en-US" sz="1400" dirty="0"/>
           </a:p>
         </p:txBody>
       </p:sp>
@@ -10768,24 +10807,24 @@
         </p:nvSpPr>
         <p:spPr>
           <a:xfrm>
-            <a:off x="4937760" y="3566160"/>
-            <a:ext cx="3566160" cy="502920"/>
-          </a:xfrm>
-          <a:prstGeom prst="rect">
-            <a:avLst/>
-          </a:prstGeom>
-          <a:noFill/>
-          <a:ln/>
-        </p:spPr>
-        <p:txBody>
-          <a:bodyPr wrap="square" lIns="0" tIns="0" rIns="0" bIns="0" rtlCol="0" anchor="ctr"/>
-          <a:lstStyle/>
-          <a:p>
-            <a:pPr indent="0" marL="0">
-              <a:buNone/>
-            </a:pPr>
-            <a:r>
-              <a:rPr lang="en-US" sz="1300" dirty="0">
+            <a:off x="5029200" y="3566160"/>
+            <a:ext cx="3474720" cy="457200"/>
+          </a:xfrm>
+          <a:prstGeom prst="rect">
+            <a:avLst/>
+          </a:prstGeom>
+          <a:noFill/>
+          <a:ln/>
+        </p:spPr>
+        <p:txBody>
+          <a:bodyPr wrap="square" lIns="0" tIns="0" rIns="0" bIns="0" rtlCol="0" anchor="ctr"/>
+          <a:lstStyle/>
+          <a:p>
+            <a:pPr indent="0" marL="0">
+              <a:buNone/>
+            </a:pPr>
+            <a:r>
+              <a:rPr lang="en-US" sz="1400" dirty="0">
                 <a:solidFill>
                   <a:srgbClr val="334155"/>
                 </a:solidFill>
@@ -10793,9 +10832,9 @@
                 <a:ea typeface="Calibri" pitchFamily="34" charset="-122"/>
                 <a:cs typeface="Calibri" pitchFamily="34" charset="-120"/>
               </a:rPr>
-              <a:t>▸  历史日报 Draft PR 需合并或归档</a:t>
-            </a:r>
-            <a:endParaRPr lang="en-US" sz="1300" dirty="0"/>
+              <a:t>▸  历史日报 Draft 需归档</a:t>
+            </a:r>
+            <a:endParaRPr lang="en-US" sz="1400" dirty="0"/>
           </a:p>
         </p:txBody>
       </p:sp>
@@ -10807,7 +10846,7 @@
         </p:nvSpPr>
         <p:spPr>
           <a:xfrm>
-            <a:off x="457200" y="4800600"/>
+            <a:off x="457200" y="4828032"/>
             <a:ext cx="8229600" cy="228600"/>
           </a:xfrm>
           <a:prstGeom prst="rect">
@@ -10824,9 +10863,9 @@
               <a:buNone/>
             </a:pPr>
             <a:r>
-              <a:rPr lang="en-US" sz="1000" dirty="0">
-                <a:solidFill>
-                  <a:srgbClr val="64748B"/>
+              <a:rPr lang="en-US" sz="1100" dirty="0">
+                <a:solidFill>
+                  <a:srgbClr val="475569"/>
                 </a:solidFill>
                 <a:latin typeface="Calibri" pitchFamily="34" charset="0"/>
                 <a:ea typeface="Calibri" pitchFamily="34" charset="-122"/>
@@ -10834,7 +10873,7 @@
               </a:rPr>
               <a:t>yu-ai-code-mother  ·  每日项目状态  ·  2026-08-05</a:t>
             </a:r>
-            <a:endParaRPr lang="en-US" sz="1000" dirty="0"/>
+            <a:endParaRPr lang="en-US" sz="1100" dirty="0"/>
           </a:p>
         </p:txBody>
       </p:sp>

</xml_diff>